<commit_message>
feat: bind NodeKit campaign to production proof
</commit_message>
<xml_diff>
--- a/changes/nodekit-proof-campaign-2026-07-20/presentation/exports/nodekit-proof-campaign-2026-07-20.draft.pptx
+++ b/changes/nodekit-proof-campaign-2026-07-20/presentation/exports/nodekit-proof-campaign-2026-07-20.draft.pptx
@@ -760,15 +760,17 @@
 Evidence IDs: E1_FACTORY_ACCEPTANCE, E2_NODEKIT_RELEASE.
 NodeSlide sources
 [source_2d056b939eda709bebd6e733061843bb] DRAFT — NodeKit launches NodeKit through proof-carrying product work — creation brief
-Citation: By the end, a technical reviewer should understand that NodeKit is a portable application contract and verification path, see exactly which product slices have passed which gates, and know where the system remains local, blocked, or planned.
+Citation: By the end, a technical reviewer should understand that NodeKit is a portable application contract and verification path, see exactly which product slices have passed which gates, and know where the remaining release boundaries are local, blocked, or pending publication.
 Every material claim must remain bound to the supplied Change Story evidence.
-This deck is a draft and does not assert external publish readiness.
+This deck is a draft because video and publication receipts remain separate gates.
 https://github.com/HomenShum/node-platform/releases/tag/v0.2.0
 https://github.com/HomenShum/agentic-rl-research-lab/releases/tag/v0.1.0-diagnostic-baselines
 https://github.com/HomenShum/agentic-rl-research-lab/releases/tag/v0.1.0-diagnostic-baselines
 https://www.anthropic.com/news/rare-disease-research-grants
 https://medium.com/intuitionmachine/from-loop-engineering-to-graph-engineering-d3ebeb08511c
 https://github.com/HomenShum/agentic-rl-research-lab/actions/runs/29799453044
+https://founder-quest-graph.vercel.app/
+https://github.com/HomenShum/founder-quest-graph/releases/tag/v0.1.1-production-certified
 Disclaimer: Internal working material
 [source_6be783f5420cdb61288cf2af7102eb07] github.com · supplied source 1
 Citation: https://github.com/HomenShum/node-platform/releases/tag/v0.2.0
@@ -790,7 +792,15 @@
 Citation: https://github.com/HomenShum/agentic-rl-research-lab/actions/runs/29799453044
 URL: https://github.com/HomenShum/agentic-rl-research-lab/actions/runs/29799453044
 Disclaimer: User-supplied linked evidence; verify reuse rights before external publication.
-[source_82043fb8f2d95853e479440f80f0a692] NodeKit governed Change Story
+[source_684f243592d39cb600b18490b8275383] founder-quest-graph.vercel.app · supplied source 6
+Citation: https://founder-quest-graph.vercel.app/
+URL: https://founder-quest-graph.vercel.app/
+Disclaimer: User-supplied linked evidence; verify reuse rights before external publication.
+[source_8ddd465bfc1338d75949e78459dd907f] github.com · supplied source 7
+Citation: https://github.com/HomenShum/founder-quest-graph/releases/tag/v0.1.1-production-certified
+URL: https://github.com/HomenShum/founder-quest-graph/releases/tag/v0.1.1-production-certified
+Disclaimer: User-supplied linked evidence; verify reuse rights before external publication.
+[source_57cbcc2af5ecc7a8c85c2bbca2d37b95] NodeKit governed Change Story
 Citation: Uploaded file: NodeKit governed Change Story
 {
   "change": {
@@ -827,7 +837,7 @@
       "technical founders and investors"
     ],
     "changeType": "release-campaign",
-    "communicationJob": "By the end, a technical reviewer should understand that NodeKit is a portable application contract and verification path, see exactly which product slices have passed which gates, and know where the system remains local, blocked, or planned.",
+    "communicationJob": "By the end, a technical reviewer should understand that NodeKit is a portable application contract and verification path, see exactly which product slices have passed which gates, and know where the remaining release boundaries are local, blocked, or pending publication.",
     "decision": [
       "Use one thin NodeKit manifest, filesystem-discovered capabilities, composed evaluations, and content-addressed proof receipts.",
       "Prove the system through independent generated applications and preserve failed gates as first-class evidence.",
@@ -837,10 +847,10 @@
       "NodeKit v0.2.0 is source-released on GitHub; npm publication is blocked by registry authentication.",
       "The Casca lab is local-ready, not production-proven.",
       "The current Agentic RL lab trains a deterministic behavior-cloning baseline; it does not perform gradient-based reinforcement learning.",
-      "Founder Quest Graph claims remain planned until its exact deployed revision passes the fresh-user journey."
+      "Founder Quest Graph is production-proven only as a synthetic, read-only workflow with no durable writes or remote Neo4j writes; it does not prove any external approval."
     ],
     "id": "nodekit-proof-campaign-2026-07-20",
-    "nextMilestone": "Deploy and production-prove the read-only synthetic Founder Quest Graph, then export and publish an evidence-bound deck, video, and campaign.",
+    "nextMilestone": "Regenerate the evidence-bound deck and walkthrough from the verified Founder Quest production receipt, then publish only the exact approved campaign and preserve the resulting public-URL receipts.",
     "presentationTier": 4,
     "previousState": [
       "Agent application scaffolding, runtime, domain evaluation, browser QA, and release evidence were rebuilt manually per project.",
@@ -933,14 +943,35 @@
         "text": "The preregistered Agentic RL live-model baseline failed closed when the Azure-only, zero-data-retention OpenRouter route returned HTTP 404; no retry, fallback, token usage, or cost was accepted."
       },
       {
-        "evidenceIds": [],
+        "evidenceIds": [
+          "E12_FOUNDER_QUEST_PRODUCTION",
+          "E13_FOUNDER_QUEST_RELEASE"
+        ],
         "id": "C5_FOUNDER_QUEST_PRODUCT",
         "limitations": [
-          "This claim must remain future tense until deployment and fresh-user browser proof pass."
-        ],
-        "scope": {},
-        "status": "planned",
-        "text": "Founder Quest Graph provides a read-only synthetic quest rail, bounded graph workspace, source-backed answer panel, and proof surface on an exact hosted revision."
+          "The journey is synthetic and read-only; no durable writes or remote Neo4j writes occur.",
+          "The 15 hosted checks and four isolated browser contexts prove this bounded production journey, not government, bank, legal, tax, regulatory, or other external approval."
+        ],
+        "scope": {
+          "appHash": "973ea7cbd8039e963bab1ff604bc0180bf0457f9a334b9b9dc0f77062f103e20",
+          "artifactManifestHashesVerified": 25,
+          "commit": "dc5fba2467576d5ded3d3ac6bf4d142316410c86",
+          "configHash": "973ea7cbd8039e963bab1ff604bc0180bf0457f9a334b9b9dc0f77062f103e20",
+          "evidenceCommit": "04579137a85f4ce18db61e6e7c0f25ff7b1d42b6",
+          "graphRevision": "ng1_c9334138",
+          "hostedChecksPassed": 15,
+          "hostedDeploymentCertified": true,
+          "isolatedBrowserContexts": 4,
+          "productionReceiptDigest": "023154fb77698b8704932ccaa9a0736a252a6de8b1ea46da3f76675ffac9f49c",
+          "productionUrl": "https://founder-quest-graph.vercel.app/",
+          "releaseAuditIssues": 0,
+          "releaseLevel": "production-certified",
+          "releaseReady": true,
+          "testsPassed": 18,
+          "unifiedReleaseReceiptDigest": "3366a2466bfed64e07c70324babbb9d2eb369965e7e1930c9f00909b199bb5a5"
+        },
+        "status": "verified",
+        "text": "Founder Quest Graph provides a read-only synthetic quest rail, bounded graph workspace, source-backed answer panel, and proof surface on an exact production revision that passed all 15 hosted checks."
       },
       {
         "evidenceIds": [
@@ -1008,7 +1039,7 @@
       {
         "id": "L5_FOUNDERQUEST_SYNTHETIC",
         "severity": "product-boundary",
-        "text": "Founder Quest Graph uses a fictional California LLC. Synthetic receipts may prove workflow readiness but never government, bank, insurance, payment-provider, legal, tax, or regulatory approval."
+        "text": "Founder Quest Graph uses a fictional California LLC in a read-only production journey. It performs no durable writes or remote Neo4j writes. Its receipts prove the bounded hosted workflow, never government, bank, insurance, payment-provider, legal, tax, regulatory, or other external approval."
       },
       {
         "id": "L6_NO_ANTHROPIC_AFFILIATION",
@@ -1025,7 +1056,7 @@
   }
 }
 Disclaimer: User supplied
-[source_eb5bb5f501f64e2f3fef3daf2cf79fa1] NodeKit evidence index
+[source_5511824e405b08e12b749fa04a98fd3f] NodeKit evidence index
 Citation: Uploaded file: NodeKit evidence index
 {
   "evidence": [
@@ -1104,15 +1135,29 @@
       "kind": "continuous-integration",
       "scope": "agentic-rl-research-lab@e1b114c486fbe26703688ab6481331659081b083; offline quality workflow passed",
       "url": "https://github.com/HomenShum/agentic-rl-research-lab/actions/runs/29799453044"
+    },
+    {
+      "id": "E12_FOUNDER_QUEST_PRODUCTION",
+      "kind": "production-browser-proof",
+      "receiptDigest": "023154fb77698b8704932ccaa9a0736a252a6de8b1ea46da3f76675ffac9f49c",
+      "scope": "founder-quest-graph@dc5fba2467576d5ded3d3ac6bf4d142316410c86; evidence 04579137a85f4ce18db61e6e7c0f25ff7b1d42b6; app/config 973ea7cbd8039e963bab1ff604bc0180bf0457f9a334b9b9dc0f77062f103e20; graph ng1_c9334138; 15/15 hosted checks; four isolated desktop/mobile light/dark contexts; zero browser, network, or cross-origin errors; synthetic read-only; no durable or remote Neo4j writes",
+      "url": "https://founder-quest-graph.vercel.app/"
+    },
+    {
+      "id": "E13_FOUNDER_QUEST_RELEASE",
+      "kind": "public-release",
+      "receiptDigest": "3366a2466bfed64e07c70324babbb9d2eb369965e7e1930c9f00909b199bb5a5",
+      "scope": "v0.1.1-production-certified; releaseReady=true; hostedDeploymentCertified=true; 18/18 tests; 25/25 artifact-manifest hashes verified byte-for-byte in a fresh Windows worktree; final independent release re-audit found zero remaining issues",
+      "url": "https://github.com/HomenShum/founder-quest-graph/releases/tag/v0.1.1-production-certified"
     }
   ],
   "schemaVersion": "nodekit.evidence-index/v1"
 }
 Disclaimer: User supplied
-[source_627f2cf2736066cd2c65dd72c5897641] NodeKit slide design plans
+[source_8c6f5fffd84efed8377f8fa8e8f5f68a] NodeKit slide design plans
 Citation: Uploaded file: NodeKit slide design plans
 {
-  "communicationJob": "By the end, a technical reviewer should understand what NodeKit now proves, which real product slices support the claim, and which release gates remain open.",
+  "communicationJob": "By the end, a technical reviewer should understand what NodeKit now proves, which real product slices support the claim, and which artifact and publication gates remain open.",
   "schemaVersion": "nodeslide.design-plan/v1",
   "slides": [
     {
@@ -1252,26 +1297,29 @@
     },
     {
       "audienceQuestion": "What does the graph make possible for a user?",
-      "body": "After an exact hosted revision and fresh-user journey pass, the planned read-only demo will connect quests, sources, and proof.",
+      "body": "Read-only Founder Quest connects quests, a bounded graph, sourced answers, authority boundaries, and proof in four isolated browser contexts.",
       "bullets": [
-        "Quest rail plus bounded graph",
-        "Source-backed answer plus authority class",
-        "No hosted-revision proof yet"
+        "Source dc5fba2 · evidence 0457913",
+        "App/config 973ea7cb · graph ng1_c9334138",
+        "18 / 18 tests · 25 / 25 artifact hashes"
       ],
       "claimIds": [
         "C5_FOUNDER_QUEST_PRODUCT"
       ],
       "density": "medium",
-      "dominantVisual": "Optional draft Founder Quest screenshot with quest rail, bounded graph, answer panel, and proof strip.",
-      "evidenceIds": [],
+      "dominantVisual": "Verified production Founder Quest view with quest rail, bounded graph, answer panel, and proof strip.",
+      "evidenceIds": [
+        "E12_FOUNDER_QUEST_PRODUCTION",
+        "E13_FOUNDER_QUEST_RELEASE"
+      ],
       "id": "S6",
       "job": "Introduce Founder Quest as the connected product surface.",
       "metric": {
-        "label": "hosted revision and fresh-user proof still required",
-        "value": "PLANNED"
+        "label": "hosted checks passed; synthetic and read-only",
+        "value": "15 / 15"
       },
       "narrativeRole": "product-reveal",
-      "takeaway": "Founder Quest remains planned until hosted and fresh-user proof pass."
+      "takeaway": "Founder Quest passed all 15 hosted checks on one exact production revision."
     },
     {
       "audienceQuestion": "How would a researcher use this today?",
@@ -1301,7 +1349,7 @@
     },
     {
       "audienceQuestion": "How do the pieces improve, and what should reviewers do next?",
-      "body": "Research, build, evaluation, proof, presentation, and feedback can watch one another; only external sources, commits, artifacts, and outcomes close the graph.",
+      "body": "Research, build, evaluation, proof, presentation, and feedback can watch one another. Only external anchors close the graph.",
       "bullets": [
         "Researcher, builder, or operator",
         "Sources, commits, exports, and outcomes",
@@ -1426,15 +1474,17 @@
 Evidence IDs: none; planned content only.
 NodeSlide sources
 [source_2d056b939eda709bebd6e733061843bb] DRAFT — NodeKit launches NodeKit through proof-carrying product work — creation brief
-Citation: By the end, a technical reviewer should understand that NodeKit is a portable application contract and verification path, see exactly which product slices have passed which gates, and know where the system remains local, blocked, or planned.
+Citation: By the end, a technical reviewer should understand that NodeKit is a portable application contract and verification path, see exactly which product slices have passed which gates, and know where the remaining release boundaries are local, blocked, or pending publication.
 Every material claim must remain bound to the supplied Change Story evidence.
-This deck is a draft and does not assert external publish readiness.
+This deck is a draft because video and publication receipts remain separate gates.
 https://github.com/HomenShum/node-platform/releases/tag/v0.2.0
 https://github.com/HomenShum/agentic-rl-research-lab/releases/tag/v0.1.0-diagnostic-baselines
 https://github.com/HomenShum/agentic-rl-research-lab/releases/tag/v0.1.0-diagnostic-baselines
 https://www.anthropic.com/news/rare-disease-research-grants
 https://medium.com/intuitionmachine/from-loop-engineering-to-graph-engineering-d3ebeb08511c
 https://github.com/HomenShum/agentic-rl-research-lab/actions/runs/29799453044
+https://founder-quest-graph.vercel.app/
+https://github.com/HomenShum/founder-quest-graph/releases/tag/v0.1.1-production-certified
 Disclaimer: Internal working material
 [source_6be783f5420cdb61288cf2af7102eb07] github.com · supplied source 1
 Citation: https://github.com/HomenShum/node-platform/releases/tag/v0.2.0
@@ -1456,7 +1506,15 @@
 Citation: https://github.com/HomenShum/agentic-rl-research-lab/actions/runs/29799453044
 URL: https://github.com/HomenShum/agentic-rl-research-lab/actions/runs/29799453044
 Disclaimer: User-supplied linked evidence; verify reuse rights before external publication.
-[source_82043fb8f2d95853e479440f80f0a692] NodeKit governed Change Story
+[source_684f243592d39cb600b18490b8275383] founder-quest-graph.vercel.app · supplied source 6
+Citation: https://founder-quest-graph.vercel.app/
+URL: https://founder-quest-graph.vercel.app/
+Disclaimer: User-supplied linked evidence; verify reuse rights before external publication.
+[source_8ddd465bfc1338d75949e78459dd907f] github.com · supplied source 7
+Citation: https://github.com/HomenShum/founder-quest-graph/releases/tag/v0.1.1-production-certified
+URL: https://github.com/HomenShum/founder-quest-graph/releases/tag/v0.1.1-production-certified
+Disclaimer: User-supplied linked evidence; verify reuse rights before external publication.
+[source_57cbcc2af5ecc7a8c85c2bbca2d37b95] NodeKit governed Change Story
 Citation: Uploaded file: NodeKit governed Change Story
 {
   "change": {
@@ -1493,7 +1551,7 @@
       "technical founders and investors"
     ],
     "changeType": "release-campaign",
-    "communicationJob": "By the end, a technical reviewer should understand that NodeKit is a portable application contract and verification path, see exactly which product slices have passed which gates, and know where the system remains local, blocked, or planned.",
+    "communicationJob": "By the end, a technical reviewer should understand that NodeKit is a portable application contract and verification path, see exactly which product slices have passed which gates, and know where the remaining release boundaries are local, blocked, or pending publication.",
     "decision": [
       "Use one thin NodeKit manifest, filesystem-discovered capabilities, composed evaluations, and content-addressed proof receipts.",
       "Prove the system through independent generated applications and preserve failed gates as first-class evidence.",
@@ -1503,10 +1561,10 @@
       "NodeKit v0.2.0 is source-released on GitHub; npm publication is blocked by registry authentication.",
       "The Casca lab is local-ready, not production-proven.",
       "The current Agentic RL lab trains a deterministic behavior-cloning baseline; it does not perform gradient-based reinforcement learning.",
-      "Founder Quest Graph claims remain planned until its exact deployed revision passes the fresh-user journey."
+      "Founder Quest Graph is production-proven only as a synthetic, read-only workflow with no durable writes or remote Neo4j writes; it does not prove any external approval."
     ],
     "id": "nodekit-proof-campaign-2026-07-20",
-    "nextMilestone": "Deploy and production-prove the read-only synthetic Founder Quest Graph, then export and publish an evidence-bound deck, video, and campaign.",
+    "nextMilestone": "Regenerate the evidence-bound deck and walkthrough from the verified Founder Quest production receipt, then publish only the exact approved campaign and preserve the resulting public-URL receipts.",
     "presentationTier": 4,
     "previousState": [
       "Agent application scaffolding, runtime, domain evaluation, browser QA, and release evidence were rebuilt manually per project.",
@@ -1599,14 +1657,35 @@
         "text": "The preregistered Agentic RL live-model baseline failed closed when the Azure-only, zero-data-retention OpenRouter route returned HTTP 404; no retry, fallback, token usage, or cost was accepted."
       },
       {
-        "evidenceIds": [],
+        "evidenceIds": [
+          "E12_FOUNDER_QUEST_PRODUCTION",
+          "E13_FOUNDER_QUEST_RELEASE"
+        ],
         "id": "C5_FOUNDER_QUEST_PRODUCT",
         "limitations": [
-          "This claim must remain future tense until deployment and fresh-user browser proof pass."
-        ],
-        "scope": {},
-        "status": "planned",
-        "text": "Founder Quest Graph provides a read-only synthetic quest rail, bounded graph workspace, source-backed answer panel, and proof surface on an exact hosted revision."
+          "The journey is synthetic and read-only; no durable writes or remote Neo4j writes occur.",
+          "The 15 hosted checks and four isolated browser contexts prove this bounded production journey, not government, bank, legal, tax, regulatory, or other external approval."
+        ],
+        "scope": {
+          "appHash": "973ea7cbd8039e963bab1ff604bc0180bf0457f9a334b9b9dc0f77062f103e20",
+          "artifactManifestHashesVerified": 25,
+          "commit": "dc5fba2467576d5ded3d3ac6bf4d142316410c86",
+          "configHash": "973ea7cbd8039e963bab1ff604bc0180bf0457f9a334b9b9dc0f77062f103e20",
+          "evidenceCommit": "04579137a85f4ce18db61e6e7c0f25ff7b1d42b6",
+          "graphRevision": "ng1_c9334138",
+          "hostedChecksPassed": 15,
+          "hostedDeploymentCertified": true,
+          "isolatedBrowserContexts": 4,
+          "productionReceiptDigest": "023154fb77698b8704932ccaa9a0736a252a6de8b1ea46da3f76675ffac9f49c",
+          "productionUrl": "https://founder-quest-graph.vercel.app/",
+          "releaseAuditIssues": 0,
+          "releaseLevel": "production-certified",
+          "releaseReady": true,
+          "testsPassed": 18,
+          "unifiedReleaseReceiptDigest": "3366a2466bfed64e07c70324babbb9d2eb369965e7e1930c9f00909b199bb5a5"
+        },
+        "status": "verified",
+        "text": "Founder Quest Graph provides a read-only synthetic quest rail, bounded graph workspace, source-backed answer panel, and proof surface on an exact production revision that passed all 15 hosted checks."
       },
       {
         "evidenceIds": [
@@ -1674,7 +1753,7 @@
       {
         "id": "L5_FOUNDERQUEST_SYNTHETIC",
         "severity": "product-boundary",
-        "text": "Founder Quest Graph uses a fictional California LLC. Synthetic receipts may prove workflow readiness but never government, bank, insurance, payment-provider, legal, tax, or regulatory approval."
+        "text": "Founder Quest Graph uses a fictional California LLC in a read-only production journey. It performs no durable writes or remote Neo4j writes. Its receipts prove the bounded hosted workflow, never government, bank, insurance, payment-provider, legal, tax, regulatory, or other external approval."
       },
       {
         "id": "L6_NO_ANTHROPIC_AFFILIATION",
@@ -1691,7 +1770,7 @@
   }
 }
 Disclaimer: User supplied
-[source_eb5bb5f501f64e2f3fef3daf2cf79fa1] NodeKit evidence index
+[source_5511824e405b08e12b749fa04a98fd3f] NodeKit evidence index
 Citation: Uploaded file: NodeKit evidence index
 {
   "evidence": [
@@ -1770,15 +1849,29 @@
       "kind": "continuous-integration",
       "scope": "agentic-rl-research-lab@e1b114c486fbe26703688ab6481331659081b083; offline quality workflow passed",
       "url": "https://github.com/HomenShum/agentic-rl-research-lab/actions/runs/29799453044"
+    },
+    {
+      "id": "E12_FOUNDER_QUEST_PRODUCTION",
+      "kind": "production-browser-proof",
+      "receiptDigest": "023154fb77698b8704932ccaa9a0736a252a6de8b1ea46da3f76675ffac9f49c",
+      "scope": "founder-quest-graph@dc5fba2467576d5ded3d3ac6bf4d142316410c86; evidence 04579137a85f4ce18db61e6e7c0f25ff7b1d42b6; app/config 973ea7cbd8039e963bab1ff604bc0180bf0457f9a334b9b9dc0f77062f103e20; graph ng1_c9334138; 15/15 hosted checks; four isolated desktop/mobile light/dark contexts; zero browser, network, or cross-origin errors; synthetic read-only; no durable or remote Neo4j writes",
+      "url": "https://founder-quest-graph.vercel.app/"
+    },
+    {
+      "id": "E13_FOUNDER_QUEST_RELEASE",
+      "kind": "public-release",
+      "receiptDigest": "3366a2466bfed64e07c70324babbb9d2eb369965e7e1930c9f00909b199bb5a5",
+      "scope": "v0.1.1-production-certified; releaseReady=true; hostedDeploymentCertified=true; 18/18 tests; 25/25 artifact-manifest hashes verified byte-for-byte in a fresh Windows worktree; final independent release re-audit found zero remaining issues",
+      "url": "https://github.com/HomenShum/founder-quest-graph/releases/tag/v0.1.1-production-certified"
     }
   ],
   "schemaVersion": "nodekit.evidence-index/v1"
 }
 Disclaimer: User supplied
-[source_627f2cf2736066cd2c65dd72c5897641] NodeKit slide design plans
+[source_8c6f5fffd84efed8377f8fa8e8f5f68a] NodeKit slide design plans
 Citation: Uploaded file: NodeKit slide design plans
 {
-  "communicationJob": "By the end, a technical reviewer should understand what NodeKit now proves, which real product slices support the claim, and which release gates remain open.",
+  "communicationJob": "By the end, a technical reviewer should understand what NodeKit now proves, which real product slices support the claim, and which artifact and publication gates remain open.",
   "schemaVersion": "nodeslide.design-plan/v1",
   "slides": [
     {
@@ -1918,26 +2011,29 @@
     },
     {
       "audienceQuestion": "What does the graph make possible for a user?",
-      "body": "After an exact hosted revision and fresh-user journey pass, the planned read-only demo will connect quests, sources, and proof.",
+      "body": "Read-only Founder Quest connects quests, a bounded graph, sourced answers, authority boundaries, and proof in four isolated browser contexts.",
       "bullets": [
-        "Quest rail plus bounded graph",
-        "Source-backed answer plus authority class",
-        "No hosted-revision proof yet"
+        "Source dc5fba2 · evidence 0457913",
+        "App/config 973ea7cb · graph ng1_c9334138",
+        "18 / 18 tests · 25 / 25 artifact hashes"
       ],
       "claimIds": [
         "C5_FOUNDER_QUEST_PRODUCT"
       ],
       "density": "medium",
-      "dominantVisual": "Optional draft Founder Quest screenshot with quest rail, bounded graph, answer panel, and proof strip.",
-      "evidenceIds": [],
+      "dominantVisual": "Verified production Founder Quest view with quest rail, bounded graph, answer panel, and proof strip.",
+      "evidenceIds": [
+        "E12_FOUNDER_QUEST_PRODUCTION",
+        "E13_FOUNDER_QUEST_RELEASE"
+      ],
       "id": "S6",
       "job": "Introduce Founder Quest as the connected product surface.",
       "metric": {
-        "label": "hosted revision and fresh-user proof still required",
-        "value": "PLANNED"
+        "label": "hosted checks passed; synthetic and read-only",
+        "value": "15 / 15"
       },
       "narrativeRole": "product-reveal",
-      "takeaway": "Founder Quest remains planned until hosted and fresh-user proof pass."
+      "takeaway": "Founder Quest passed all 15 hosted checks on one exact production revision."
     },
     {
       "audienceQuestion": "How would a researcher use this today?",
@@ -1967,7 +2063,7 @@
     },
     {
       "audienceQuestion": "How do the pieces improve, and what should reviewers do next?",
-      "body": "Research, build, evaluation, proof, presentation, and feedback can watch one another; only external sources, commits, artifacts, and outcomes close the graph.",
+      "body": "Research, build, evaluation, proof, presentation, and feedback can watch one another. Only external anchors close the graph.",
       "bullets": [
         "Researcher, builder, or operator",
         "Sources, commits, exports, and outcomes",
@@ -2092,15 +2188,17 @@
 Evidence IDs: E1_FACTORY_ACCEPTANCE, E2_NODEKIT_RELEASE.
 NodeSlide sources
 [source_2d056b939eda709bebd6e733061843bb] DRAFT — NodeKit launches NodeKit through proof-carrying product work — creation brief
-Citation: By the end, a technical reviewer should understand that NodeKit is a portable application contract and verification path, see exactly which product slices have passed which gates, and know where the system remains local, blocked, or planned.
+Citation: By the end, a technical reviewer should understand that NodeKit is a portable application contract and verification path, see exactly which product slices have passed which gates, and know where the remaining release boundaries are local, blocked, or pending publication.
 Every material claim must remain bound to the supplied Change Story evidence.
-This deck is a draft and does not assert external publish readiness.
+This deck is a draft because video and publication receipts remain separate gates.
 https://github.com/HomenShum/node-platform/releases/tag/v0.2.0
 https://github.com/HomenShum/agentic-rl-research-lab/releases/tag/v0.1.0-diagnostic-baselines
 https://github.com/HomenShum/agentic-rl-research-lab/releases/tag/v0.1.0-diagnostic-baselines
 https://www.anthropic.com/news/rare-disease-research-grants
 https://medium.com/intuitionmachine/from-loop-engineering-to-graph-engineering-d3ebeb08511c
 https://github.com/HomenShum/agentic-rl-research-lab/actions/runs/29799453044
+https://founder-quest-graph.vercel.app/
+https://github.com/HomenShum/founder-quest-graph/releases/tag/v0.1.1-production-certified
 Disclaimer: Internal working material
 [source_6be783f5420cdb61288cf2af7102eb07] github.com · supplied source 1
 Citation: https://github.com/HomenShum/node-platform/releases/tag/v0.2.0
@@ -2122,7 +2220,15 @@
 Citation: https://github.com/HomenShum/agentic-rl-research-lab/actions/runs/29799453044
 URL: https://github.com/HomenShum/agentic-rl-research-lab/actions/runs/29799453044
 Disclaimer: User-supplied linked evidence; verify reuse rights before external publication.
-[source_82043fb8f2d95853e479440f80f0a692] NodeKit governed Change Story
+[source_684f243592d39cb600b18490b8275383] founder-quest-graph.vercel.app · supplied source 6
+Citation: https://founder-quest-graph.vercel.app/
+URL: https://founder-quest-graph.vercel.app/
+Disclaimer: User-supplied linked evidence; verify reuse rights before external publication.
+[source_8ddd465bfc1338d75949e78459dd907f] github.com · supplied source 7
+Citation: https://github.com/HomenShum/founder-quest-graph/releases/tag/v0.1.1-production-certified
+URL: https://github.com/HomenShum/founder-quest-graph/releases/tag/v0.1.1-production-certified
+Disclaimer: User-supplied linked evidence; verify reuse rights before external publication.
+[source_57cbcc2af5ecc7a8c85c2bbca2d37b95] NodeKit governed Change Story
 Citation: Uploaded file: NodeKit governed Change Story
 {
   "change": {
@@ -2159,7 +2265,7 @@
       "technical founders and investors"
     ],
     "changeType": "release-campaign",
-    "communicationJob": "By the end, a technical reviewer should understand that NodeKit is a portable application contract and verification path, see exactly which product slices have passed which gates, and know where the system remains local, blocked, or planned.",
+    "communicationJob": "By the end, a technical reviewer should understand that NodeKit is a portable application contract and verification path, see exactly which product slices have passed which gates, and know where the remaining release boundaries are local, blocked, or pending publication.",
     "decision": [
       "Use one thin NodeKit manifest, filesystem-discovered capabilities, composed evaluations, and content-addressed proof receipts.",
       "Prove the system through independent generated applications and preserve failed gates as first-class evidence.",
@@ -2169,10 +2275,10 @@
       "NodeKit v0.2.0 is source-released on GitHub; npm publication is blocked by registry authentication.",
       "The Casca lab is local-ready, not production-proven.",
       "The current Agentic RL lab trains a deterministic behavior-cloning baseline; it does not perform gradient-based reinforcement learning.",
-      "Founder Quest Graph claims remain planned until its exact deployed revision passes the fresh-user journey."
+      "Founder Quest Graph is production-proven only as a synthetic, read-only workflow with no durable writes or remote Neo4j writes; it does not prove any external approval."
     ],
     "id": "nodekit-proof-campaign-2026-07-20",
-    "nextMilestone": "Deploy and production-prove the read-only synthetic Founder Quest Graph, then export and publish an evidence-bound deck, video, and campaign.",
+    "nextMilestone": "Regenerate the evidence-bound deck and walkthrough from the verified Founder Quest production receipt, then publish only the exact approved campaign and preserve the resulting public-URL receipts.",
     "presentationTier": 4,
     "previousState": [
       "Agent application scaffolding, runtime, domain evaluation, browser QA, and release evidence were rebuilt manually per project.",
@@ -2265,14 +2371,35 @@
         "text": "The preregistered Agentic RL live-model baseline failed closed when the Azure-only, zero-data-retention OpenRouter route returned HTTP 404; no retry, fallback, token usage, or cost was accepted."
       },
       {
-        "evidenceIds": [],
+        "evidenceIds": [
+          "E12_FOUNDER_QUEST_PRODUCTION",
+          "E13_FOUNDER_QUEST_RELEASE"
+        ],
         "id": "C5_FOUNDER_QUEST_PRODUCT",
         "limitations": [
-          "This claim must remain future tense until deployment and fresh-user browser proof pass."
-        ],
-        "scope": {},
-        "status": "planned",
-        "text": "Founder Quest Graph provides a read-only synthetic quest rail, bounded graph workspace, source-backed answer panel, and proof surface on an exact hosted revision."
+          "The journey is synthetic and read-only; no durable writes or remote Neo4j writes occur.",
+          "The 15 hosted checks and four isolated browser contexts prove this bounded production journey, not government, bank, legal, tax, regulatory, or other external approval."
+        ],
+        "scope": {
+          "appHash": "973ea7cbd8039e963bab1ff604bc0180bf0457f9a334b9b9dc0f77062f103e20",
+          "artifactManifestHashesVerified": 25,
+          "commit": "dc5fba2467576d5ded3d3ac6bf4d142316410c86",
+          "configHash": "973ea7cbd8039e963bab1ff604bc0180bf0457f9a334b9b9dc0f77062f103e20",
+          "evidenceCommit": "04579137a85f4ce18db61e6e7c0f25ff7b1d42b6",
+          "graphRevision": "ng1_c9334138",
+          "hostedChecksPassed": 15,
+          "hostedDeploymentCertified": true,
+          "isolatedBrowserContexts": 4,
+          "productionReceiptDigest": "023154fb77698b8704932ccaa9a0736a252a6de8b1ea46da3f76675ffac9f49c",
+          "productionUrl": "https://founder-quest-graph.vercel.app/",
+          "releaseAuditIssues": 0,
+          "releaseLevel": "production-certified",
+          "releaseReady": true,
+          "testsPassed": 18,
+          "unifiedReleaseReceiptDigest": "3366a2466bfed64e07c70324babbb9d2eb369965e7e1930c9f00909b199bb5a5"
+        },
+        "status": "verified",
+        "text": "Founder Quest Graph provides a read-only synthetic quest rail, bounded graph workspace, source-backed answer panel, and proof surface on an exact production revision that passed all 15 hosted checks."
       },
       {
         "evidenceIds": [
@@ -2340,7 +2467,7 @@
       {
         "id": "L5_FOUNDERQUEST_SYNTHETIC",
         "severity": "product-boundary",
-        "text": "Founder Quest Graph uses a fictional California LLC. Synthetic receipts may prove workflow readiness but never government, bank, insurance, payment-provider, legal, tax, or regulatory approval."
+        "text": "Founder Quest Graph uses a fictional California LLC in a read-only production journey. It performs no durable writes or remote Neo4j writes. Its receipts prove the bounded hosted workflow, never government, bank, insurance, payment-provider, legal, tax, regulatory, or other external approval."
       },
       {
         "id": "L6_NO_ANTHROPIC_AFFILIATION",
@@ -2357,7 +2484,7 @@
   }
 }
 Disclaimer: User supplied
-[source_eb5bb5f501f64e2f3fef3daf2cf79fa1] NodeKit evidence index
+[source_5511824e405b08e12b749fa04a98fd3f] NodeKit evidence index
 Citation: Uploaded file: NodeKit evidence index
 {
   "evidence": [
@@ -2436,15 +2563,29 @@
       "kind": "continuous-integration",
       "scope": "agentic-rl-research-lab@e1b114c486fbe26703688ab6481331659081b083; offline quality workflow passed",
       "url": "https://github.com/HomenShum/agentic-rl-research-lab/actions/runs/29799453044"
+    },
+    {
+      "id": "E12_FOUNDER_QUEST_PRODUCTION",
+      "kind": "production-browser-proof",
+      "receiptDigest": "023154fb77698b8704932ccaa9a0736a252a6de8b1ea46da3f76675ffac9f49c",
+      "scope": "founder-quest-graph@dc5fba2467576d5ded3d3ac6bf4d142316410c86; evidence 04579137a85f4ce18db61e6e7c0f25ff7b1d42b6; app/config 973ea7cbd8039e963bab1ff604bc0180bf0457f9a334b9b9dc0f77062f103e20; graph ng1_c9334138; 15/15 hosted checks; four isolated desktop/mobile light/dark contexts; zero browser, network, or cross-origin errors; synthetic read-only; no durable or remote Neo4j writes",
+      "url": "https://founder-quest-graph.vercel.app/"
+    },
+    {
+      "id": "E13_FOUNDER_QUEST_RELEASE",
+      "kind": "public-release",
+      "receiptDigest": "3366a2466bfed64e07c70324babbb9d2eb369965e7e1930c9f00909b199bb5a5",
+      "scope": "v0.1.1-production-certified; releaseReady=true; hostedDeploymentCertified=true; 18/18 tests; 25/25 artifact-manifest hashes verified byte-for-byte in a fresh Windows worktree; final independent release re-audit found zero remaining issues",
+      "url": "https://github.com/HomenShum/founder-quest-graph/releases/tag/v0.1.1-production-certified"
     }
   ],
   "schemaVersion": "nodekit.evidence-index/v1"
 }
 Disclaimer: User supplied
-[source_627f2cf2736066cd2c65dd72c5897641] NodeKit slide design plans
+[source_8c6f5fffd84efed8377f8fa8e8f5f68a] NodeKit slide design plans
 Citation: Uploaded file: NodeKit slide design plans
 {
-  "communicationJob": "By the end, a technical reviewer should understand what NodeKit now proves, which real product slices support the claim, and which release gates remain open.",
+  "communicationJob": "By the end, a technical reviewer should understand what NodeKit now proves, which real product slices support the claim, and which artifact and publication gates remain open.",
   "schemaVersion": "nodeslide.design-plan/v1",
   "slides": [
     {
@@ -2584,26 +2725,29 @@
     },
     {
       "audienceQuestion": "What does the graph make possible for a user?",
-      "body": "After an exact hosted revision and fresh-user journey pass, the planned read-only demo will connect quests, sources, and proof.",
+      "body": "Read-only Founder Quest connects quests, a bounded graph, sourced answers, authority boundaries, and proof in four isolated browser contexts.",
       "bullets": [
-        "Quest rail plus bounded graph",
-        "Source-backed answer plus authority class",
-        "No hosted-revision proof yet"
+        "Source dc5fba2 · evidence 0457913",
+        "App/config 973ea7cb · graph ng1_c9334138",
+        "18 / 18 tests · 25 / 25 artifact hashes"
       ],
       "claimIds": [
         "C5_FOUNDER_QUEST_PRODUCT"
       ],
       "density": "medium",
-      "dominantVisual": "Optional draft Founder Quest screenshot with quest rail, bounded graph, answer panel, and proof strip.",
-      "evidenceIds": [],
+      "dominantVisual": "Verified production Founder Quest view with quest rail, bounded graph, answer panel, and proof strip.",
+      "evidenceIds": [
+        "E12_FOUNDER_QUEST_PRODUCTION",
+        "E13_FOUNDER_QUEST_RELEASE"
+      ],
       "id": "S6",
       "job": "Introduce Founder Quest as the connected product surface.",
       "metric": {
-        "label": "hosted revision and fresh-user proof still required",
-        "value": "PLANNED"
+        "label": "hosted checks passed; synthetic and read-only",
+        "value": "15 / 15"
       },
       "narrativeRole": "product-reveal",
-      "takeaway": "Founder Quest remains planned until hosted and fresh-user proof pass."
+      "takeaway": "Founder Quest passed all 15 hosted checks on one exact production revision."
     },
     {
       "audienceQuestion": "How would a researcher use this today?",
@@ -2633,7 +2777,7 @@
     },
     {
       "audienceQuestion": "How do the pieces improve, and what should reviewers do next?",
-      "body": "Research, build, evaluation, proof, presentation, and feedback can watch one another; only external sources, commits, artifacts, and outcomes close the graph.",
+      "body": "Research, build, evaluation, proof, presentation, and feedback can watch one another. Only external anchors close the graph.",
       "bullets": [
         "Researcher, builder, or operator",
         "Sources, commits, exports, and outcomes",
@@ -2758,15 +2902,17 @@
 Evidence IDs: E3_CASCA_RELEASE, E4_CASCA_BROWSER, E5_CASCA_LIVE.
 NodeSlide sources
 [source_2d056b939eda709bebd6e733061843bb] DRAFT — NodeKit launches NodeKit through proof-carrying product work — creation brief
-Citation: By the end, a technical reviewer should understand that NodeKit is a portable application contract and verification path, see exactly which product slices have passed which gates, and know where the system remains local, blocked, or planned.
+Citation: By the end, a technical reviewer should understand that NodeKit is a portable application contract and verification path, see exactly which product slices have passed which gates, and know where the remaining release boundaries are local, blocked, or pending publication.
 Every material claim must remain bound to the supplied Change Story evidence.
-This deck is a draft and does not assert external publish readiness.
+This deck is a draft because video and publication receipts remain separate gates.
 https://github.com/HomenShum/node-platform/releases/tag/v0.2.0
 https://github.com/HomenShum/agentic-rl-research-lab/releases/tag/v0.1.0-diagnostic-baselines
 https://github.com/HomenShum/agentic-rl-research-lab/releases/tag/v0.1.0-diagnostic-baselines
 https://www.anthropic.com/news/rare-disease-research-grants
 https://medium.com/intuitionmachine/from-loop-engineering-to-graph-engineering-d3ebeb08511c
 https://github.com/HomenShum/agentic-rl-research-lab/actions/runs/29799453044
+https://founder-quest-graph.vercel.app/
+https://github.com/HomenShum/founder-quest-graph/releases/tag/v0.1.1-production-certified
 Disclaimer: Internal working material
 [source_6be783f5420cdb61288cf2af7102eb07] github.com · supplied source 1
 Citation: https://github.com/HomenShum/node-platform/releases/tag/v0.2.0
@@ -2788,7 +2934,15 @@
 Citation: https://github.com/HomenShum/agentic-rl-research-lab/actions/runs/29799453044
 URL: https://github.com/HomenShum/agentic-rl-research-lab/actions/runs/29799453044
 Disclaimer: User-supplied linked evidence; verify reuse rights before external publication.
-[source_82043fb8f2d95853e479440f80f0a692] NodeKit governed Change Story
+[source_684f243592d39cb600b18490b8275383] founder-quest-graph.vercel.app · supplied source 6
+Citation: https://founder-quest-graph.vercel.app/
+URL: https://founder-quest-graph.vercel.app/
+Disclaimer: User-supplied linked evidence; verify reuse rights before external publication.
+[source_8ddd465bfc1338d75949e78459dd907f] github.com · supplied source 7
+Citation: https://github.com/HomenShum/founder-quest-graph/releases/tag/v0.1.1-production-certified
+URL: https://github.com/HomenShum/founder-quest-graph/releases/tag/v0.1.1-production-certified
+Disclaimer: User-supplied linked evidence; verify reuse rights before external publication.
+[source_57cbcc2af5ecc7a8c85c2bbca2d37b95] NodeKit governed Change Story
 Citation: Uploaded file: NodeKit governed Change Story
 {
   "change": {
@@ -2825,7 +2979,7 @@
       "technical founders and investors"
     ],
     "changeType": "release-campaign",
-    "communicationJob": "By the end, a technical reviewer should understand that NodeKit is a portable application contract and verification path, see exactly which product slices have passed which gates, and know where the system remains local, blocked, or planned.",
+    "communicationJob": "By the end, a technical reviewer should understand that NodeKit is a portable application contract and verification path, see exactly which product slices have passed which gates, and know where the remaining release boundaries are local, blocked, or pending publication.",
     "decision": [
       "Use one thin NodeKit manifest, filesystem-discovered capabilities, composed evaluations, and content-addressed proof receipts.",
       "Prove the system through independent generated applications and preserve failed gates as first-class evidence.",
@@ -2835,10 +2989,10 @@
       "NodeKit v0.2.0 is source-released on GitHub; npm publication is blocked by registry authentication.",
       "The Casca lab is local-ready, not production-proven.",
       "The current Agentic RL lab trains a deterministic behavior-cloning baseline; it does not perform gradient-based reinforcement learning.",
-      "Founder Quest Graph claims remain planned until its exact deployed revision passes the fresh-user journey."
+      "Founder Quest Graph is production-proven only as a synthetic, read-only workflow with no durable writes or remote Neo4j writes; it does not prove any external approval."
     ],
     "id": "nodekit-proof-campaign-2026-07-20",
-    "nextMilestone": "Deploy and production-prove the read-only synthetic Founder Quest Graph, then export and publish an evidence-bound deck, video, and campaign.",
+    "nextMilestone": "Regenerate the evidence-bound deck and walkthrough from the verified Founder Quest production receipt, then publish only the exact approved campaign and preserve the resulting public-URL receipts.",
     "presentationTier": 4,
     "previousState": [
       "Agent application scaffolding, runtime, domain evaluation, browser QA, and release evidence were rebuilt manually per project.",
@@ -2931,14 +3085,35 @@
         "text": "The preregistered Agentic RL live-model baseline failed closed when the Azure-only, zero-data-retention OpenRouter route returned HTTP 404; no retry, fallback, token usage, or cost was accepted."
       },
       {
-        "evidenceIds": [],
+        "evidenceIds": [
+          "E12_FOUNDER_QUEST_PRODUCTION",
+          "E13_FOUNDER_QUEST_RELEASE"
+        ],
         "id": "C5_FOUNDER_QUEST_PRODUCT",
         "limitations": [
-          "This claim must remain future tense until deployment and fresh-user browser proof pass."
-        ],
-        "scope": {},
-        "status": "planned",
-        "text": "Founder Quest Graph provides a read-only synthetic quest rail, bounded graph workspace, source-backed answer panel, and proof surface on an exact hosted revision."
+          "The journey is synthetic and read-only; no durable writes or remote Neo4j writes occur.",
+          "The 15 hosted checks and four isolated browser contexts prove this bounded production journey, not government, bank, legal, tax, regulatory, or other external approval."
+        ],
+        "scope": {
+          "appHash": "973ea7cbd8039e963bab1ff604bc0180bf0457f9a334b9b9dc0f77062f103e20",
+          "artifactManifestHashesVerified": 25,
+          "commit": "dc5fba2467576d5ded3d3ac6bf4d142316410c86",
+          "configHash": "973ea7cbd8039e963bab1ff604bc0180bf0457f9a334b9b9dc0f77062f103e20",
+          "evidenceCommit": "04579137a85f4ce18db61e6e7c0f25ff7b1d42b6",
+          "graphRevision": "ng1_c9334138",
+          "hostedChecksPassed": 15,
+          "hostedDeploymentCertified": true,
+          "isolatedBrowserContexts": 4,
+          "productionReceiptDigest": "023154fb77698b8704932ccaa9a0736a252a6de8b1ea46da3f76675ffac9f49c",
+          "productionUrl": "https://founder-quest-graph.vercel.app/",
+          "releaseAuditIssues": 0,
+          "releaseLevel": "production-certified",
+          "releaseReady": true,
+          "testsPassed": 18,
+          "unifiedReleaseReceiptDigest": "3366a2466bfed64e07c70324babbb9d2eb369965e7e1930c9f00909b199bb5a5"
+        },
+        "status": "verified",
+        "text": "Founder Quest Graph provides a read-only synthetic quest rail, bounded graph workspace, source-backed answer panel, and proof surface on an exact production revision that passed all 15 hosted checks."
       },
       {
         "evidenceIds": [
@@ -3006,7 +3181,7 @@
       {
         "id": "L5_FOUNDERQUEST_SYNTHETIC",
         "severity": "product-boundary",
-        "text": "Founder Quest Graph uses a fictional California LLC. Synthetic receipts may prove workflow readiness but never government, bank, insurance, payment-provider, legal, tax, or regulatory approval."
+        "text": "Founder Quest Graph uses a fictional California LLC in a read-only production journey. It performs no durable writes or remote Neo4j writes. Its receipts prove the bounded hosted workflow, never government, bank, insurance, payment-provider, legal, tax, regulatory, or other external approval."
       },
       {
         "id": "L6_NO_ANTHROPIC_AFFILIATION",
@@ -3023,7 +3198,7 @@
   }
 }
 Disclaimer: User supplied
-[source_eb5bb5f501f64e2f3fef3daf2cf79fa1] NodeKit evidence index
+[source_5511824e405b08e12b749fa04a98fd3f] NodeKit evidence index
 Citation: Uploaded file: NodeKit evidence index
 {
   "evidence": [
@@ -3102,15 +3277,29 @@
       "kind": "continuous-integration",
       "scope": "agentic-rl-research-lab@e1b114c486fbe26703688ab6481331659081b083; offline quality workflow passed",
       "url": "https://github.com/HomenShum/agentic-rl-research-lab/actions/runs/29799453044"
+    },
+    {
+      "id": "E12_FOUNDER_QUEST_PRODUCTION",
+      "kind": "production-browser-proof",
+      "receiptDigest": "023154fb77698b8704932ccaa9a0736a252a6de8b1ea46da3f76675ffac9f49c",
+      "scope": "founder-quest-graph@dc5fba2467576d5ded3d3ac6bf4d142316410c86; evidence 04579137a85f4ce18db61e6e7c0f25ff7b1d42b6; app/config 973ea7cbd8039e963bab1ff604bc0180bf0457f9a334b9b9dc0f77062f103e20; graph ng1_c9334138; 15/15 hosted checks; four isolated desktop/mobile light/dark contexts; zero browser, network, or cross-origin errors; synthetic read-only; no durable or remote Neo4j writes",
+      "url": "https://founder-quest-graph.vercel.app/"
+    },
+    {
+      "id": "E13_FOUNDER_QUEST_RELEASE",
+      "kind": "public-release",
+      "receiptDigest": "3366a2466bfed64e07c70324babbb9d2eb369965e7e1930c9f00909b199bb5a5",
+      "scope": "v0.1.1-production-certified; releaseReady=true; hostedDeploymentCertified=true; 18/18 tests; 25/25 artifact-manifest hashes verified byte-for-byte in a fresh Windows worktree; final independent release re-audit found zero remaining issues",
+      "url": "https://github.com/HomenShum/founder-quest-graph/releases/tag/v0.1.1-production-certified"
     }
   ],
   "schemaVersion": "nodekit.evidence-index/v1"
 }
 Disclaimer: User supplied
-[source_627f2cf2736066cd2c65dd72c5897641] NodeKit slide design plans
+[source_8c6f5fffd84efed8377f8fa8e8f5f68a] NodeKit slide design plans
 Citation: Uploaded file: NodeKit slide design plans
 {
-  "communicationJob": "By the end, a technical reviewer should understand what NodeKit now proves, which real product slices support the claim, and which release gates remain open.",
+  "communicationJob": "By the end, a technical reviewer should understand what NodeKit now proves, which real product slices support the claim, and which artifact and publication gates remain open.",
   "schemaVersion": "nodeslide.design-plan/v1",
   "slides": [
     {
@@ -3250,26 +3439,29 @@
     },
     {
       "audienceQuestion": "What does the graph make possible for a user?",
-      "body": "After an exact hosted revision and fresh-user journey pass, the planned read-only demo will connect quests, sources, and proof.",
+      "body": "Read-only Founder Quest connects quests, a bounded graph, sourced answers, authority boundaries, and proof in four isolated browser contexts.",
       "bullets": [
-        "Quest rail plus bounded graph",
-        "Source-backed answer plus authority class",
-        "No hosted-revision proof yet"
+        "Source dc5fba2 · evidence 0457913",
+        "App/config 973ea7cb · graph ng1_c9334138",
+        "18 / 18 tests · 25 / 25 artifact hashes"
       ],
       "claimIds": [
         "C5_FOUNDER_QUEST_PRODUCT"
       ],
       "density": "medium",
-      "dominantVisual": "Optional draft Founder Quest screenshot with quest rail, bounded graph, answer panel, and proof strip.",
-      "evidenceIds": [],
+      "dominantVisual": "Verified production Founder Quest view with quest rail, bounded graph, answer panel, and proof strip.",
+      "evidenceIds": [
+        "E12_FOUNDER_QUEST_PRODUCTION",
+        "E13_FOUNDER_QUEST_RELEASE"
+      ],
       "id": "S6",
       "job": "Introduce Founder Quest as the connected product surface.",
       "metric": {
-        "label": "hosted revision and fresh-user proof still required",
-        "value": "PLANNED"
+        "label": "hosted checks passed; synthetic and read-only",
+        "value": "15 / 15"
       },
       "narrativeRole": "product-reveal",
-      "takeaway": "Founder Quest remains planned until hosted and fresh-user proof pass."
+      "takeaway": "Founder Quest passed all 15 hosted checks on one exact production revision."
     },
     {
       "audienceQuestion": "How would a researcher use this today?",
@@ -3299,7 +3491,7 @@
     },
     {
       "audienceQuestion": "How do the pieces improve, and what should reviewers do next?",
-      "body": "Research, build, evaluation, proof, presentation, and feedback can watch one another; only external sources, commits, artifacts, and outcomes close the graph.",
+      "body": "Research, build, evaluation, proof, presentation, and feedback can watch one another. Only external anchors close the graph.",
       "bullets": [
         "Researcher, builder, or operator",
         "Sources, commits, exports, and outcomes",
@@ -3424,15 +3616,17 @@
 Evidence IDs: E6_RL_RELEASE, E7_RL_HELDOUT, E8_RL_LIVE_BLOCKED, E11_RL_CI.
 NodeSlide sources
 [source_2d056b939eda709bebd6e733061843bb] DRAFT — NodeKit launches NodeKit through proof-carrying product work — creation brief
-Citation: By the end, a technical reviewer should understand that NodeKit is a portable application contract and verification path, see exactly which product slices have passed which gates, and know where the system remains local, blocked, or planned.
+Citation: By the end, a technical reviewer should understand that NodeKit is a portable application contract and verification path, see exactly which product slices have passed which gates, and know where the remaining release boundaries are local, blocked, or pending publication.
 Every material claim must remain bound to the supplied Change Story evidence.
-This deck is a draft and does not assert external publish readiness.
+This deck is a draft because video and publication receipts remain separate gates.
 https://github.com/HomenShum/node-platform/releases/tag/v0.2.0
 https://github.com/HomenShum/agentic-rl-research-lab/releases/tag/v0.1.0-diagnostic-baselines
 https://github.com/HomenShum/agentic-rl-research-lab/releases/tag/v0.1.0-diagnostic-baselines
 https://www.anthropic.com/news/rare-disease-research-grants
 https://medium.com/intuitionmachine/from-loop-engineering-to-graph-engineering-d3ebeb08511c
 https://github.com/HomenShum/agentic-rl-research-lab/actions/runs/29799453044
+https://founder-quest-graph.vercel.app/
+https://github.com/HomenShum/founder-quest-graph/releases/tag/v0.1.1-production-certified
 Disclaimer: Internal working material
 [source_6be783f5420cdb61288cf2af7102eb07] github.com · supplied source 1
 Citation: https://github.com/HomenShum/node-platform/releases/tag/v0.2.0
@@ -3454,7 +3648,15 @@
 Citation: https://github.com/HomenShum/agentic-rl-research-lab/actions/runs/29799453044
 URL: https://github.com/HomenShum/agentic-rl-research-lab/actions/runs/29799453044
 Disclaimer: User-supplied linked evidence; verify reuse rights before external publication.
-[source_82043fb8f2d95853e479440f80f0a692] NodeKit governed Change Story
+[source_684f243592d39cb600b18490b8275383] founder-quest-graph.vercel.app · supplied source 6
+Citation: https://founder-quest-graph.vercel.app/
+URL: https://founder-quest-graph.vercel.app/
+Disclaimer: User-supplied linked evidence; verify reuse rights before external publication.
+[source_8ddd465bfc1338d75949e78459dd907f] github.com · supplied source 7
+Citation: https://github.com/HomenShum/founder-quest-graph/releases/tag/v0.1.1-production-certified
+URL: https://github.com/HomenShum/founder-quest-graph/releases/tag/v0.1.1-production-certified
+Disclaimer: User-supplied linked evidence; verify reuse rights before external publication.
+[source_57cbcc2af5ecc7a8c85c2bbca2d37b95] NodeKit governed Change Story
 Citation: Uploaded file: NodeKit governed Change Story
 {
   "change": {
@@ -3491,7 +3693,7 @@
       "technical founders and investors"
     ],
     "changeType": "release-campaign",
-    "communicationJob": "By the end, a technical reviewer should understand that NodeKit is a portable application contract and verification path, see exactly which product slices have passed which gates, and know where the system remains local, blocked, or planned.",
+    "communicationJob": "By the end, a technical reviewer should understand that NodeKit is a portable application contract and verification path, see exactly which product slices have passed which gates, and know where the remaining release boundaries are local, blocked, or pending publication.",
     "decision": [
       "Use one thin NodeKit manifest, filesystem-discovered capabilities, composed evaluations, and content-addressed proof receipts.",
       "Prove the system through independent generated applications and preserve failed gates as first-class evidence.",
@@ -3501,10 +3703,10 @@
       "NodeKit v0.2.0 is source-released on GitHub; npm publication is blocked by registry authentication.",
       "The Casca lab is local-ready, not production-proven.",
       "The current Agentic RL lab trains a deterministic behavior-cloning baseline; it does not perform gradient-based reinforcement learning.",
-      "Founder Quest Graph claims remain planned until its exact deployed revision passes the fresh-user journey."
+      "Founder Quest Graph is production-proven only as a synthetic, read-only workflow with no durable writes or remote Neo4j writes; it does not prove any external approval."
     ],
     "id": "nodekit-proof-campaign-2026-07-20",
-    "nextMilestone": "Deploy and production-prove the read-only synthetic Founder Quest Graph, then export and publish an evidence-bound deck, video, and campaign.",
+    "nextMilestone": "Regenerate the evidence-bound deck and walkthrough from the verified Founder Quest production receipt, then publish only the exact approved campaign and preserve the resulting public-URL receipts.",
     "presentationTier": 4,
     "previousState": [
       "Agent application scaffolding, runtime, domain evaluation, browser QA, and release evidence were rebuilt manually per project.",
@@ -3597,14 +3799,35 @@
         "text": "The preregistered Agentic RL live-model baseline failed closed when the Azure-only, zero-data-retention OpenRouter route returned HTTP 404; no retry, fallback, token usage, or cost was accepted."
       },
       {
-        "evidenceIds": [],
+        "evidenceIds": [
+          "E12_FOUNDER_QUEST_PRODUCTION",
+          "E13_FOUNDER_QUEST_RELEASE"
+        ],
         "id": "C5_FOUNDER_QUEST_PRODUCT",
         "limitations": [
-          "This claim must remain future tense until deployment and fresh-user browser proof pass."
-        ],
-        "scope": {},
-        "status": "planned",
-        "text": "Founder Quest Graph provides a read-only synthetic quest rail, bounded graph workspace, source-backed answer panel, and proof surface on an exact hosted revision."
+          "The journey is synthetic and read-only; no durable writes or remote Neo4j writes occur.",
+          "The 15 hosted checks and four isolated browser contexts prove this bounded production journey, not government, bank, legal, tax, regulatory, or other external approval."
+        ],
+        "scope": {
+          "appHash": "973ea7cbd8039e963bab1ff604bc0180bf0457f9a334b9b9dc0f77062f103e20",
+          "artifactManifestHashesVerified": 25,
+          "commit": "dc5fba2467576d5ded3d3ac6bf4d142316410c86",
+          "configHash": "973ea7cbd8039e963bab1ff604bc0180bf0457f9a334b9b9dc0f77062f103e20",
+          "evidenceCommit": "04579137a85f4ce18db61e6e7c0f25ff7b1d42b6",
+          "graphRevision": "ng1_c9334138",
+          "hostedChecksPassed": 15,
+          "hostedDeploymentCertified": true,
+          "isolatedBrowserContexts": 4,
+          "productionReceiptDigest": "023154fb77698b8704932ccaa9a0736a252a6de8b1ea46da3f76675ffac9f49c",
+          "productionUrl": "https://founder-quest-graph.vercel.app/",
+          "releaseAuditIssues": 0,
+          "releaseLevel": "production-certified",
+          "releaseReady": true,
+          "testsPassed": 18,
+          "unifiedReleaseReceiptDigest": "3366a2466bfed64e07c70324babbb9d2eb369965e7e1930c9f00909b199bb5a5"
+        },
+        "status": "verified",
+        "text": "Founder Quest Graph provides a read-only synthetic quest rail, bounded graph workspace, source-backed answer panel, and proof surface on an exact production revision that passed all 15 hosted checks."
       },
       {
         "evidenceIds": [
@@ -3672,7 +3895,7 @@
       {
         "id": "L5_FOUNDERQUEST_SYNTHETIC",
         "severity": "product-boundary",
-        "text": "Founder Quest Graph uses a fictional California LLC. Synthetic receipts may prove workflow readiness but never government, bank, insurance, payment-provider, legal, tax, or regulatory approval."
+        "text": "Founder Quest Graph uses a fictional California LLC in a read-only production journey. It performs no durable writes or remote Neo4j writes. Its receipts prove the bounded hosted workflow, never government, bank, insurance, payment-provider, legal, tax, regulatory, or other external approval."
       },
       {
         "id": "L6_NO_ANTHROPIC_AFFILIATION",
@@ -3689,7 +3912,7 @@
   }
 }
 Disclaimer: User supplied
-[source_eb5bb5f501f64e2f3fef3daf2cf79fa1] NodeKit evidence index
+[source_5511824e405b08e12b749fa04a98fd3f] NodeKit evidence index
 Citation: Uploaded file: NodeKit evidence index
 {
   "evidence": [
@@ -3768,15 +3991,29 @@
       "kind": "continuous-integration",
       "scope": "agentic-rl-research-lab@e1b114c486fbe26703688ab6481331659081b083; offline quality workflow passed",
       "url": "https://github.com/HomenShum/agentic-rl-research-lab/actions/runs/29799453044"
+    },
+    {
+      "id": "E12_FOUNDER_QUEST_PRODUCTION",
+      "kind": "production-browser-proof",
+      "receiptDigest": "023154fb77698b8704932ccaa9a0736a252a6de8b1ea46da3f76675ffac9f49c",
+      "scope": "founder-quest-graph@dc5fba2467576d5ded3d3ac6bf4d142316410c86; evidence 04579137a85f4ce18db61e6e7c0f25ff7b1d42b6; app/config 973ea7cbd8039e963bab1ff604bc0180bf0457f9a334b9b9dc0f77062f103e20; graph ng1_c9334138; 15/15 hosted checks; four isolated desktop/mobile light/dark contexts; zero browser, network, or cross-origin errors; synthetic read-only; no durable or remote Neo4j writes",
+      "url": "https://founder-quest-graph.vercel.app/"
+    },
+    {
+      "id": "E13_FOUNDER_QUEST_RELEASE",
+      "kind": "public-release",
+      "receiptDigest": "3366a2466bfed64e07c70324babbb9d2eb369965e7e1930c9f00909b199bb5a5",
+      "scope": "v0.1.1-production-certified; releaseReady=true; hostedDeploymentCertified=true; 18/18 tests; 25/25 artifact-manifest hashes verified byte-for-byte in a fresh Windows worktree; final independent release re-audit found zero remaining issues",
+      "url": "https://github.com/HomenShum/founder-quest-graph/releases/tag/v0.1.1-production-certified"
     }
   ],
   "schemaVersion": "nodekit.evidence-index/v1"
 }
 Disclaimer: User supplied
-[source_627f2cf2736066cd2c65dd72c5897641] NodeKit slide design plans
+[source_8c6f5fffd84efed8377f8fa8e8f5f68a] NodeKit slide design plans
 Citation: Uploaded file: NodeKit slide design plans
 {
-  "communicationJob": "By the end, a technical reviewer should understand what NodeKit now proves, which real product slices support the claim, and which release gates remain open.",
+  "communicationJob": "By the end, a technical reviewer should understand what NodeKit now proves, which real product slices support the claim, and which artifact and publication gates remain open.",
   "schemaVersion": "nodeslide.design-plan/v1",
   "slides": [
     {
@@ -3916,26 +4153,29 @@
     },
     {
       "audienceQuestion": "What does the graph make possible for a user?",
-      "body": "After an exact hosted revision and fresh-user journey pass, the planned read-only demo will connect quests, sources, and proof.",
+      "body": "Read-only Founder Quest connects quests, a bounded graph, sourced answers, authority boundaries, and proof in four isolated browser contexts.",
       "bullets": [
-        "Quest rail plus bounded graph",
-        "Source-backed answer plus authority class",
-        "No hosted-revision proof yet"
+        "Source dc5fba2 · evidence 0457913",
+        "App/config 973ea7cb · graph ng1_c9334138",
+        "18 / 18 tests · 25 / 25 artifact hashes"
       ],
       "claimIds": [
         "C5_FOUNDER_QUEST_PRODUCT"
       ],
       "density": "medium",
-      "dominantVisual": "Optional draft Founder Quest screenshot with quest rail, bounded graph, answer panel, and proof strip.",
-      "evidenceIds": [],
+      "dominantVisual": "Verified production Founder Quest view with quest rail, bounded graph, answer panel, and proof strip.",
+      "evidenceIds": [
+        "E12_FOUNDER_QUEST_PRODUCTION",
+        "E13_FOUNDER_QUEST_RELEASE"
+      ],
       "id": "S6",
       "job": "Introduce Founder Quest as the connected product surface.",
       "metric": {
-        "label": "hosted revision and fresh-user proof still required",
-        "value": "PLANNED"
+        "label": "hosted checks passed; synthetic and read-only",
+        "value": "15 / 15"
       },
       "narrativeRole": "product-reveal",
-      "takeaway": "Founder Quest remains planned until hosted and fresh-user proof pass."
+      "takeaway": "Founder Quest passed all 15 hosted checks on one exact production revision."
     },
     {
       "audienceQuestion": "How would a researcher use this today?",
@@ -3965,7 +4205,7 @@
     },
     {
       "audienceQuestion": "How do the pieces improve, and what should reviewers do next?",
-      "body": "Research, build, evaluation, proof, presentation, and feedback can watch one another; only external sources, commits, artifacts, and outcomes close the graph.",
+      "body": "Research, build, evaluation, proof, presentation, and feedback can watch one another. Only external anchors close the graph.",
       "bullets": [
         "Researcher, builder, or operator",
         "Sources, commits, exports, and outcomes",
@@ -4083,21 +4323,31 @@
             <a:r>
               <a:rPr lang="en-US" dirty="0"/>
               <a:t>DRAFT PRESENTATION — external publish readiness is not asserted.
-Replace this note with exact production evidence only after the public read-only demo
-passes. The product should show applicable quests, a bounded graph neighborhood, a
-source-backed answer, authority class, and evidence/proof status.
-Evidence IDs: none; planned content only.
+The public read-only synthetic product passed all 15 hosted checks on source commit
+dc5fba2467576d5ded3d3ac6bf4d142316410c86 and evidence commit
+04579137a85f4ce18db61e6e7c0f25ff7b1d42b6. The same app/config hash is
+973ea7cbd8039e963bab1ff604bc0180bf0457f9a334b9b9dc0f77062f103e20, and the graph
+revision is ng1_c9334138. Four isolated desktop/mobile light/dark contexts recorded
+zero browser, network, or cross-origin errors. The unified release receipt is
+production-certified, release-ready, and hosted-deployment-certified; a fresh Windows
+worktree verified all 25 artifact-manifest hashes byte-for-byte. The final independent
+release re-audit found zero remaining issues, and the suite passed 18/18 tests. Keep
+the boundary explicit: the journey is synthetic and read-only, with no durable writes
+or remote Neo4j writes, and it does not prove external approval.
+Evidence IDs: E12_FOUNDER_QUEST_PRODUCTION, E13_FOUNDER_QUEST_RELEASE.
 NodeSlide sources
 [source_2d056b939eda709bebd6e733061843bb] DRAFT — NodeKit launches NodeKit through proof-carrying product work — creation brief
-Citation: By the end, a technical reviewer should understand that NodeKit is a portable application contract and verification path, see exactly which product slices have passed which gates, and know where the system remains local, blocked, or planned.
+Citation: By the end, a technical reviewer should understand that NodeKit is a portable application contract and verification path, see exactly which product slices have passed which gates, and know where the remaining release boundaries are local, blocked, or pending publication.
 Every material claim must remain bound to the supplied Change Story evidence.
-This deck is a draft and does not assert external publish readiness.
+This deck is a draft because video and publication receipts remain separate gates.
 https://github.com/HomenShum/node-platform/releases/tag/v0.2.0
 https://github.com/HomenShum/agentic-rl-research-lab/releases/tag/v0.1.0-diagnostic-baselines
 https://github.com/HomenShum/agentic-rl-research-lab/releases/tag/v0.1.0-diagnostic-baselines
 https://www.anthropic.com/news/rare-disease-research-grants
 https://medium.com/intuitionmachine/from-loop-engineering-to-graph-engineering-d3ebeb08511c
 https://github.com/HomenShum/agentic-rl-research-lab/actions/runs/29799453044
+https://founder-quest-graph.vercel.app/
+https://github.com/HomenShum/founder-quest-graph/releases/tag/v0.1.1-production-certified
 Disclaimer: Internal working material
 [source_6be783f5420cdb61288cf2af7102eb07] github.com · supplied source 1
 Citation: https://github.com/HomenShum/node-platform/releases/tag/v0.2.0
@@ -4119,7 +4369,15 @@
 Citation: https://github.com/HomenShum/agentic-rl-research-lab/actions/runs/29799453044
 URL: https://github.com/HomenShum/agentic-rl-research-lab/actions/runs/29799453044
 Disclaimer: User-supplied linked evidence; verify reuse rights before external publication.
-[source_82043fb8f2d95853e479440f80f0a692] NodeKit governed Change Story
+[source_684f243592d39cb600b18490b8275383] founder-quest-graph.vercel.app · supplied source 6
+Citation: https://founder-quest-graph.vercel.app/
+URL: https://founder-quest-graph.vercel.app/
+Disclaimer: User-supplied linked evidence; verify reuse rights before external publication.
+[source_8ddd465bfc1338d75949e78459dd907f] github.com · supplied source 7
+Citation: https://github.com/HomenShum/founder-quest-graph/releases/tag/v0.1.1-production-certified
+URL: https://github.com/HomenShum/founder-quest-graph/releases/tag/v0.1.1-production-certified
+Disclaimer: User-supplied linked evidence; verify reuse rights before external publication.
+[source_57cbcc2af5ecc7a8c85c2bbca2d37b95] NodeKit governed Change Story
 Citation: Uploaded file: NodeKit governed Change Story
 {
   "change": {
@@ -4156,7 +4414,7 @@
       "technical founders and investors"
     ],
     "changeType": "release-campaign",
-    "communicationJob": "By the end, a technical reviewer should understand that NodeKit is a portable application contract and verification path, see exactly which product slices have passed which gates, and know where the system remains local, blocked, or planned.",
+    "communicationJob": "By the end, a technical reviewer should understand that NodeKit is a portable application contract and verification path, see exactly which product slices have passed which gates, and know where the remaining release boundaries are local, blocked, or pending publication.",
     "decision": [
       "Use one thin NodeKit manifest, filesystem-discovered capabilities, composed evaluations, and content-addressed proof receipts.",
       "Prove the system through independent generated applications and preserve failed gates as first-class evidence.",
@@ -4166,10 +4424,10 @@
       "NodeKit v0.2.0 is source-released on GitHub; npm publication is blocked by registry authentication.",
       "The Casca lab is local-ready, not production-proven.",
       "The current Agentic RL lab trains a deterministic behavior-cloning baseline; it does not perform gradient-based reinforcement learning.",
-      "Founder Quest Graph claims remain planned until its exact deployed revision passes the fresh-user journey."
+      "Founder Quest Graph is production-proven only as a synthetic, read-only workflow with no durable writes or remote Neo4j writes; it does not prove any external approval."
     ],
     "id": "nodekit-proof-campaign-2026-07-20",
-    "nextMilestone": "Deploy and production-prove the read-only synthetic Founder Quest Graph, then export and publish an evidence-bound deck, video, and campaign.",
+    "nextMilestone": "Regenerate the evidence-bound deck and walkthrough from the verified Founder Quest production receipt, then publish only the exact approved campaign and preserve the resulting public-URL receipts.",
     "presentationTier": 4,
     "previousState": [
       "Agent application scaffolding, runtime, domain evaluation, browser QA, and release evidence were rebuilt manually per project.",
@@ -4262,14 +4520,35 @@
         "text": "The preregistered Agentic RL live-model baseline failed closed when the Azure-only, zero-data-retention OpenRouter route returned HTTP 404; no retry, fallback, token usage, or cost was accepted."
       },
       {
-        "evidenceIds": [],
+        "evidenceIds": [
+          "E12_FOUNDER_QUEST_PRODUCTION",
+          "E13_FOUNDER_QUEST_RELEASE"
+        ],
         "id": "C5_FOUNDER_QUEST_PRODUCT",
         "limitations": [
-          "This claim must remain future tense until deployment and fresh-user browser proof pass."
-        ],
-        "scope": {},
-        "status": "planned",
-        "text": "Founder Quest Graph provides a read-only synthetic quest rail, bounded graph workspace, source-backed answer panel, and proof surface on an exact hosted revision."
+          "The journey is synthetic and read-only; no durable writes or remote Neo4j writes occur.",
+          "The 15 hosted checks and four isolated browser contexts prove this bounded production journey, not government, bank, legal, tax, regulatory, or other external approval."
+        ],
+        "scope": {
+          "appHash": "973ea7cbd8039e963bab1ff604bc0180bf0457f9a334b9b9dc0f77062f103e20",
+          "artifactManifestHashesVerified": 25,
+          "commit": "dc5fba2467576d5ded3d3ac6bf4d142316410c86",
+          "configHash": "973ea7cbd8039e963bab1ff604bc0180bf0457f9a334b9b9dc0f77062f103e20",
+          "evidenceCommit": "04579137a85f4ce18db61e6e7c0f25ff7b1d42b6",
+          "graphRevision": "ng1_c9334138",
+          "hostedChecksPassed": 15,
+          "hostedDeploymentCertified": true,
+          "isolatedBrowserContexts": 4,
+          "productionReceiptDigest": "023154fb77698b8704932ccaa9a0736a252a6de8b1ea46da3f76675ffac9f49c",
+          "productionUrl": "https://founder-quest-graph.vercel.app/",
+          "releaseAuditIssues": 0,
+          "releaseLevel": "production-certified",
+          "releaseReady": true,
+          "testsPassed": 18,
+          "unifiedReleaseReceiptDigest": "3366a2466bfed64e07c70324babbb9d2eb369965e7e1930c9f00909b199bb5a5"
+        },
+        "status": "verified",
+        "text": "Founder Quest Graph provides a read-only synthetic quest rail, bounded graph workspace, source-backed answer panel, and proof surface on an exact production revision that passed all 15 hosted checks."
       },
       {
         "evidenceIds": [
@@ -4337,7 +4616,7 @@
       {
         "id": "L5_FOUNDERQUEST_SYNTHETIC",
         "severity": "product-boundary",
-        "text": "Founder Quest Graph uses a fictional California LLC. Synthetic receipts may prove workflow readiness but never government, bank, insurance, payment-provider, legal, tax, or regulatory approval."
+        "text": "Founder Quest Graph uses a fictional California LLC in a read-only production journey. It performs no durable writes or remote Neo4j writes. Its receipts prove the bounded hosted workflow, never government, bank, insurance, payment-provider, legal, tax, regulatory, or other external approval."
       },
       {
         "id": "L6_NO_ANTHROPIC_AFFILIATION",
@@ -4354,7 +4633,7 @@
   }
 }
 Disclaimer: User supplied
-[source_eb5bb5f501f64e2f3fef3daf2cf79fa1] NodeKit evidence index
+[source_5511824e405b08e12b749fa04a98fd3f] NodeKit evidence index
 Citation: Uploaded file: NodeKit evidence index
 {
   "evidence": [
@@ -4433,15 +4712,29 @@
       "kind": "continuous-integration",
       "scope": "agentic-rl-research-lab@e1b114c486fbe26703688ab6481331659081b083; offline quality workflow passed",
       "url": "https://github.com/HomenShum/agentic-rl-research-lab/actions/runs/29799453044"
+    },
+    {
+      "id": "E12_FOUNDER_QUEST_PRODUCTION",
+      "kind": "production-browser-proof",
+      "receiptDigest": "023154fb77698b8704932ccaa9a0736a252a6de8b1ea46da3f76675ffac9f49c",
+      "scope": "founder-quest-graph@dc5fba2467576d5ded3d3ac6bf4d142316410c86; evidence 04579137a85f4ce18db61e6e7c0f25ff7b1d42b6; app/config 973ea7cbd8039e963bab1ff604bc0180bf0457f9a334b9b9dc0f77062f103e20; graph ng1_c9334138; 15/15 hosted checks; four isolated desktop/mobile light/dark contexts; zero browser, network, or cross-origin errors; synthetic read-only; no durable or remote Neo4j writes",
+      "url": "https://founder-quest-graph.vercel.app/"
+    },
+    {
+      "id": "E13_FOUNDER_QUEST_RELEASE",
+      "kind": "public-release",
+      "receiptDigest": "3366a2466bfed64e07c70324babbb9d2eb369965e7e1930c9f00909b199bb5a5",
+      "scope": "v0.1.1-production-certified; releaseReady=true; hostedDeploymentCertified=true; 18/18 tests; 25/25 artifact-manifest hashes verified byte-for-byte in a fresh Windows worktree; final independent release re-audit found zero remaining issues",
+      "url": "https://github.com/HomenShum/founder-quest-graph/releases/tag/v0.1.1-production-certified"
     }
   ],
   "schemaVersion": "nodekit.evidence-index/v1"
 }
 Disclaimer: User supplied
-[source_627f2cf2736066cd2c65dd72c5897641] NodeKit slide design plans
+[source_8c6f5fffd84efed8377f8fa8e8f5f68a] NodeKit slide design plans
 Citation: Uploaded file: NodeKit slide design plans
 {
-  "communicationJob": "By the end, a technical reviewer should understand what NodeKit now proves, which real product slices support the claim, and which release gates remain open.",
+  "communicationJob": "By the end, a technical reviewer should understand what NodeKit now proves, which real product slices support the claim, and which artifact and publication gates remain open.",
   "schemaVersion": "nodeslide.design-plan/v1",
   "slides": [
     {
@@ -4581,26 +4874,29 @@
     },
     {
       "audienceQuestion": "What does the graph make possible for a user?",
-      "body": "After an exact hosted revision and fresh-user journey pass, the planned read-only demo will connect quests, sources, and proof.",
+      "body": "Read-only Founder Quest connects quests, a bounded graph, sourced answers, authority boundaries, and proof in four isolated browser contexts.",
       "bullets": [
-        "Quest rail plus bounded graph",
-        "Source-backed answer plus authority class",
-        "No hosted-revision proof yet"
+        "Source dc5fba2 · evidence 0457913",
+        "App/config 973ea7cb · graph ng1_c9334138",
+        "18 / 18 tests · 25 / 25 artifact hashes"
       ],
       "claimIds": [
         "C5_FOUNDER_QUEST_PRODUCT"
       ],
       "density": "medium",
-      "dominantVisual": "Optional draft Founder Quest screenshot with quest rail, bounded graph, answer panel, and proof strip.",
-      "evidenceIds": [],
+      "dominantVisual": "Verified production Founder Quest view with quest rail, bounded graph, answer panel, and proof strip.",
+      "evidenceIds": [
+        "E12_FOUNDER_QUEST_PRODUCTION",
+        "E13_FOUNDER_QUEST_RELEASE"
+      ],
       "id": "S6",
       "job": "Introduce Founder Quest as the connected product surface.",
       "metric": {
-        "label": "hosted revision and fresh-user proof still required",
-        "value": "PLANNED"
+        "label": "hosted checks passed; synthetic and read-only",
+        "value": "15 / 15"
       },
       "narrativeRole": "product-reveal",
-      "takeaway": "Founder Quest remains planned until hosted and fresh-user proof pass."
+      "takeaway": "Founder Quest passed all 15 hosted checks on one exact production revision."
     },
     {
       "audienceQuestion": "How would a researcher use this today?",
@@ -4630,7 +4926,7 @@
     },
     {
       "audienceQuestion": "How do the pieces improve, and what should reviewers do next?",
-      "body": "Research, build, evaluation, proof, presentation, and feedback can watch one another; only external sources, commits, artifacts, and outcomes close the graph.",
+      "body": "Research, build, evaluation, proof, presentation, and feedback can watch one another. Only external anchors close the graph.",
       "bullets": [
         "Researcher, builder, or operator",
         "Sources, commits, exports, and outcomes",
@@ -4755,15 +5051,17 @@
 Evidence IDs: E9_ANTHROPIC_GRANT_SOURCE.
 NodeSlide sources
 [source_2d056b939eda709bebd6e733061843bb] DRAFT — NodeKit launches NodeKit through proof-carrying product work — creation brief
-Citation: By the end, a technical reviewer should understand that NodeKit is a portable application contract and verification path, see exactly which product slices have passed which gates, and know where the system remains local, blocked, or planned.
+Citation: By the end, a technical reviewer should understand that NodeKit is a portable application contract and verification path, see exactly which product slices have passed which gates, and know where the remaining release boundaries are local, blocked, or pending publication.
 Every material claim must remain bound to the supplied Change Story evidence.
-This deck is a draft and does not assert external publish readiness.
+This deck is a draft because video and publication receipts remain separate gates.
 https://github.com/HomenShum/node-platform/releases/tag/v0.2.0
 https://github.com/HomenShum/agentic-rl-research-lab/releases/tag/v0.1.0-diagnostic-baselines
 https://github.com/HomenShum/agentic-rl-research-lab/releases/tag/v0.1.0-diagnostic-baselines
 https://www.anthropic.com/news/rare-disease-research-grants
 https://medium.com/intuitionmachine/from-loop-engineering-to-graph-engineering-d3ebeb08511c
 https://github.com/HomenShum/agentic-rl-research-lab/actions/runs/29799453044
+https://founder-quest-graph.vercel.app/
+https://github.com/HomenShum/founder-quest-graph/releases/tag/v0.1.1-production-certified
 Disclaimer: Internal working material
 [source_6be783f5420cdb61288cf2af7102eb07] github.com · supplied source 1
 Citation: https://github.com/HomenShum/node-platform/releases/tag/v0.2.0
@@ -4785,7 +5083,15 @@
 Citation: https://github.com/HomenShum/agentic-rl-research-lab/actions/runs/29799453044
 URL: https://github.com/HomenShum/agentic-rl-research-lab/actions/runs/29799453044
 Disclaimer: User-supplied linked evidence; verify reuse rights before external publication.
-[source_82043fb8f2d95853e479440f80f0a692] NodeKit governed Change Story
+[source_684f243592d39cb600b18490b8275383] founder-quest-graph.vercel.app · supplied source 6
+Citation: https://founder-quest-graph.vercel.app/
+URL: https://founder-quest-graph.vercel.app/
+Disclaimer: User-supplied linked evidence; verify reuse rights before external publication.
+[source_8ddd465bfc1338d75949e78459dd907f] github.com · supplied source 7
+Citation: https://github.com/HomenShum/founder-quest-graph/releases/tag/v0.1.1-production-certified
+URL: https://github.com/HomenShum/founder-quest-graph/releases/tag/v0.1.1-production-certified
+Disclaimer: User-supplied linked evidence; verify reuse rights before external publication.
+[source_57cbcc2af5ecc7a8c85c2bbca2d37b95] NodeKit governed Change Story
 Citation: Uploaded file: NodeKit governed Change Story
 {
   "change": {
@@ -4822,7 +5128,7 @@
       "technical founders and investors"
     ],
     "changeType": "release-campaign",
-    "communicationJob": "By the end, a technical reviewer should understand that NodeKit is a portable application contract and verification path, see exactly which product slices have passed which gates, and know where the system remains local, blocked, or planned.",
+    "communicationJob": "By the end, a technical reviewer should understand that NodeKit is a portable application contract and verification path, see exactly which product slices have passed which gates, and know where the remaining release boundaries are local, blocked, or pending publication.",
     "decision": [
       "Use one thin NodeKit manifest, filesystem-discovered capabilities, composed evaluations, and content-addressed proof receipts.",
       "Prove the system through independent generated applications and preserve failed gates as first-class evidence.",
@@ -4832,10 +5138,10 @@
       "NodeKit v0.2.0 is source-released on GitHub; npm publication is blocked by registry authentication.",
       "The Casca lab is local-ready, not production-proven.",
       "The current Agentic RL lab trains a deterministic behavior-cloning baseline; it does not perform gradient-based reinforcement learning.",
-      "Founder Quest Graph claims remain planned until its exact deployed revision passes the fresh-user journey."
+      "Founder Quest Graph is production-proven only as a synthetic, read-only workflow with no durable writes or remote Neo4j writes; it does not prove any external approval."
     ],
     "id": "nodekit-proof-campaign-2026-07-20",
-    "nextMilestone": "Deploy and production-prove the read-only synthetic Founder Quest Graph, then export and publish an evidence-bound deck, video, and campaign.",
+    "nextMilestone": "Regenerate the evidence-bound deck and walkthrough from the verified Founder Quest production receipt, then publish only the exact approved campaign and preserve the resulting public-URL receipts.",
     "presentationTier": 4,
     "previousState": [
       "Agent application scaffolding, runtime, domain evaluation, browser QA, and release evidence were rebuilt manually per project.",
@@ -4928,14 +5234,35 @@
         "text": "The preregistered Agentic RL live-model baseline failed closed when the Azure-only, zero-data-retention OpenRouter route returned HTTP 404; no retry, fallback, token usage, or cost was accepted."
       },
       {
-        "evidenceIds": [],
+        "evidenceIds": [
+          "E12_FOUNDER_QUEST_PRODUCTION",
+          "E13_FOUNDER_QUEST_RELEASE"
+        ],
         "id": "C5_FOUNDER_QUEST_PRODUCT",
         "limitations": [
-          "This claim must remain future tense until deployment and fresh-user browser proof pass."
-        ],
-        "scope": {},
-        "status": "planned",
-        "text": "Founder Quest Graph provides a read-only synthetic quest rail, bounded graph workspace, source-backed answer panel, and proof surface on an exact hosted revision."
+          "The journey is synthetic and read-only; no durable writes or remote Neo4j writes occur.",
+          "The 15 hosted checks and four isolated browser contexts prove this bounded production journey, not government, bank, legal, tax, regulatory, or other external approval."
+        ],
+        "scope": {
+          "appHash": "973ea7cbd8039e963bab1ff604bc0180bf0457f9a334b9b9dc0f77062f103e20",
+          "artifactManifestHashesVerified": 25,
+          "commit": "dc5fba2467576d5ded3d3ac6bf4d142316410c86",
+          "configHash": "973ea7cbd8039e963bab1ff604bc0180bf0457f9a334b9b9dc0f77062f103e20",
+          "evidenceCommit": "04579137a85f4ce18db61e6e7c0f25ff7b1d42b6",
+          "graphRevision": "ng1_c9334138",
+          "hostedChecksPassed": 15,
+          "hostedDeploymentCertified": true,
+          "isolatedBrowserContexts": 4,
+          "productionReceiptDigest": "023154fb77698b8704932ccaa9a0736a252a6de8b1ea46da3f76675ffac9f49c",
+          "productionUrl": "https://founder-quest-graph.vercel.app/",
+          "releaseAuditIssues": 0,
+          "releaseLevel": "production-certified",
+          "releaseReady": true,
+          "testsPassed": 18,
+          "unifiedReleaseReceiptDigest": "3366a2466bfed64e07c70324babbb9d2eb369965e7e1930c9f00909b199bb5a5"
+        },
+        "status": "verified",
+        "text": "Founder Quest Graph provides a read-only synthetic quest rail, bounded graph workspace, source-backed answer panel, and proof surface on an exact production revision that passed all 15 hosted checks."
       },
       {
         "evidenceIds": [
@@ -5003,7 +5330,7 @@
       {
         "id": "L5_FOUNDERQUEST_SYNTHETIC",
         "severity": "product-boundary",
-        "text": "Founder Quest Graph uses a fictional California LLC. Synthetic receipts may prove workflow readiness but never government, bank, insurance, payment-provider, legal, tax, or regulatory approval."
+        "text": "Founder Quest Graph uses a fictional California LLC in a read-only production journey. It performs no durable writes or remote Neo4j writes. Its receipts prove the bounded hosted workflow, never government, bank, insurance, payment-provider, legal, tax, regulatory, or other external approval."
       },
       {
         "id": "L6_NO_ANTHROPIC_AFFILIATION",
@@ -5020,7 +5347,7 @@
   }
 }
 Disclaimer: User supplied
-[source_eb5bb5f501f64e2f3fef3daf2cf79fa1] NodeKit evidence index
+[source_5511824e405b08e12b749fa04a98fd3f] NodeKit evidence index
 Citation: Uploaded file: NodeKit evidence index
 {
   "evidence": [
@@ -5099,15 +5426,29 @@
       "kind": "continuous-integration",
       "scope": "agentic-rl-research-lab@e1b114c486fbe26703688ab6481331659081b083; offline quality workflow passed",
       "url": "https://github.com/HomenShum/agentic-rl-research-lab/actions/runs/29799453044"
+    },
+    {
+      "id": "E12_FOUNDER_QUEST_PRODUCTION",
+      "kind": "production-browser-proof",
+      "receiptDigest": "023154fb77698b8704932ccaa9a0736a252a6de8b1ea46da3f76675ffac9f49c",
+      "scope": "founder-quest-graph@dc5fba2467576d5ded3d3ac6bf4d142316410c86; evidence 04579137a85f4ce18db61e6e7c0f25ff7b1d42b6; app/config 973ea7cbd8039e963bab1ff604bc0180bf0457f9a334b9b9dc0f77062f103e20; graph ng1_c9334138; 15/15 hosted checks; four isolated desktop/mobile light/dark contexts; zero browser, network, or cross-origin errors; synthetic read-only; no durable or remote Neo4j writes",
+      "url": "https://founder-quest-graph.vercel.app/"
+    },
+    {
+      "id": "E13_FOUNDER_QUEST_RELEASE",
+      "kind": "public-release",
+      "receiptDigest": "3366a2466bfed64e07c70324babbb9d2eb369965e7e1930c9f00909b199bb5a5",
+      "scope": "v0.1.1-production-certified; releaseReady=true; hostedDeploymentCertified=true; 18/18 tests; 25/25 artifact-manifest hashes verified byte-for-byte in a fresh Windows worktree; final independent release re-audit found zero remaining issues",
+      "url": "https://github.com/HomenShum/founder-quest-graph/releases/tag/v0.1.1-production-certified"
     }
   ],
   "schemaVersion": "nodekit.evidence-index/v1"
 }
 Disclaimer: User supplied
-[source_627f2cf2736066cd2c65dd72c5897641] NodeKit slide design plans
+[source_8c6f5fffd84efed8377f8fa8e8f5f68a] NodeKit slide design plans
 Citation: Uploaded file: NodeKit slide design plans
 {
-  "communicationJob": "By the end, a technical reviewer should understand what NodeKit now proves, which real product slices support the claim, and which release gates remain open.",
+  "communicationJob": "By the end, a technical reviewer should understand what NodeKit now proves, which real product slices support the claim, and which artifact and publication gates remain open.",
   "schemaVersion": "nodeslide.design-plan/v1",
   "slides": [
     {
@@ -5247,26 +5588,29 @@
     },
     {
       "audienceQuestion": "What does the graph make possible for a user?",
-      "body": "After an exact hosted revision and fresh-user journey pass, the planned read-only demo will connect quests, sources, and proof.",
+      "body": "Read-only Founder Quest connects quests, a bounded graph, sourced answers, authority boundaries, and proof in four isolated browser contexts.",
       "bullets": [
-        "Quest rail plus bounded graph",
-        "Source-backed answer plus authority class",
-        "No hosted-revision proof yet"
+        "Source dc5fba2 · evidence 0457913",
+        "App/config 973ea7cb · graph ng1_c9334138",
+        "18 / 18 tests · 25 / 25 artifact hashes"
       ],
       "claimIds": [
         "C5_FOUNDER_QUEST_PRODUCT"
       ],
       "density": "medium",
-      "dominantVisual": "Optional draft Founder Quest screenshot with quest rail, bounded graph, answer panel, and proof strip.",
-      "evidenceIds": [],
+      "dominantVisual": "Verified production Founder Quest view with quest rail, bounded graph, answer panel, and proof strip.",
+      "evidenceIds": [
+        "E12_FOUNDER_QUEST_PRODUCTION",
+        "E13_FOUNDER_QUEST_RELEASE"
+      ],
       "id": "S6",
       "job": "Introduce Founder Quest as the connected product surface.",
       "metric": {
-        "label": "hosted revision and fresh-user proof still required",
-        "value": "PLANNED"
+        "label": "hosted checks passed; synthetic and read-only",
+        "value": "15 / 15"
       },
       "narrativeRole": "product-reveal",
-      "takeaway": "Founder Quest remains planned until hosted and fresh-user proof pass."
+      "takeaway": "Founder Quest passed all 15 hosted checks on one exact production revision."
     },
     {
       "audienceQuestion": "How would a researcher use this today?",
@@ -5296,7 +5640,7 @@
     },
     {
       "audienceQuestion": "How do the pieces improve, and what should reviewers do next?",
-      "body": "Research, build, evaluation, proof, presentation, and feedback can watch one another; only external sources, commits, artifacts, and outcomes close the graph.",
+      "body": "Research, build, evaluation, proof, presentation, and feedback can watch one another. Only external anchors close the graph.",
       "bullets": [
         "Researcher, builder, or operator",
         "Sources, commits, exports, and outcomes",
@@ -5423,15 +5767,17 @@
 Evidence IDs: E1_FACTORY_ACCEPTANCE, E2_NODEKIT_RELEASE, E4_CASCA_BROWSER, E10_GRAPH_OF_LOOPS_SOURCE.
 NodeSlide sources
 [source_2d056b939eda709bebd6e733061843bb] DRAFT — NodeKit launches NodeKit through proof-carrying product work — creation brief
-Citation: By the end, a technical reviewer should understand that NodeKit is a portable application contract and verification path, see exactly which product slices have passed which gates, and know where the system remains local, blocked, or planned.
+Citation: By the end, a technical reviewer should understand that NodeKit is a portable application contract and verification path, see exactly which product slices have passed which gates, and know where the remaining release boundaries are local, blocked, or pending publication.
 Every material claim must remain bound to the supplied Change Story evidence.
-This deck is a draft and does not assert external publish readiness.
+This deck is a draft because video and publication receipts remain separate gates.
 https://github.com/HomenShum/node-platform/releases/tag/v0.2.0
 https://github.com/HomenShum/agentic-rl-research-lab/releases/tag/v0.1.0-diagnostic-baselines
 https://github.com/HomenShum/agentic-rl-research-lab/releases/tag/v0.1.0-diagnostic-baselines
 https://www.anthropic.com/news/rare-disease-research-grants
 https://medium.com/intuitionmachine/from-loop-engineering-to-graph-engineering-d3ebeb08511c
 https://github.com/HomenShum/agentic-rl-research-lab/actions/runs/29799453044
+https://founder-quest-graph.vercel.app/
+https://github.com/HomenShum/founder-quest-graph/releases/tag/v0.1.1-production-certified
 Disclaimer: Internal working material
 [source_6be783f5420cdb61288cf2af7102eb07] github.com · supplied source 1
 Citation: https://github.com/HomenShum/node-platform/releases/tag/v0.2.0
@@ -5453,7 +5799,15 @@
 Citation: https://github.com/HomenShum/agentic-rl-research-lab/actions/runs/29799453044
 URL: https://github.com/HomenShum/agentic-rl-research-lab/actions/runs/29799453044
 Disclaimer: User-supplied linked evidence; verify reuse rights before external publication.
-[source_82043fb8f2d95853e479440f80f0a692] NodeKit governed Change Story
+[source_684f243592d39cb600b18490b8275383] founder-quest-graph.vercel.app · supplied source 6
+Citation: https://founder-quest-graph.vercel.app/
+URL: https://founder-quest-graph.vercel.app/
+Disclaimer: User-supplied linked evidence; verify reuse rights before external publication.
+[source_8ddd465bfc1338d75949e78459dd907f] github.com · supplied source 7
+Citation: https://github.com/HomenShum/founder-quest-graph/releases/tag/v0.1.1-production-certified
+URL: https://github.com/HomenShum/founder-quest-graph/releases/tag/v0.1.1-production-certified
+Disclaimer: User-supplied linked evidence; verify reuse rights before external publication.
+[source_57cbcc2af5ecc7a8c85c2bbca2d37b95] NodeKit governed Change Story
 Citation: Uploaded file: NodeKit governed Change Story
 {
   "change": {
@@ -5490,7 +5844,7 @@
       "technical founders and investors"
     ],
     "changeType": "release-campaign",
-    "communicationJob": "By the end, a technical reviewer should understand that NodeKit is a portable application contract and verification path, see exactly which product slices have passed which gates, and know where the system remains local, blocked, or planned.",
+    "communicationJob": "By the end, a technical reviewer should understand that NodeKit is a portable application contract and verification path, see exactly which product slices have passed which gates, and know where the remaining release boundaries are local, blocked, or pending publication.",
     "decision": [
       "Use one thin NodeKit manifest, filesystem-discovered capabilities, composed evaluations, and content-addressed proof receipts.",
       "Prove the system through independent generated applications and preserve failed gates as first-class evidence.",
@@ -5500,10 +5854,10 @@
       "NodeKit v0.2.0 is source-released on GitHub; npm publication is blocked by registry authentication.",
       "The Casca lab is local-ready, not production-proven.",
       "The current Agentic RL lab trains a deterministic behavior-cloning baseline; it does not perform gradient-based reinforcement learning.",
-      "Founder Quest Graph claims remain planned until its exact deployed revision passes the fresh-user journey."
+      "Founder Quest Graph is production-proven only as a synthetic, read-only workflow with no durable writes or remote Neo4j writes; it does not prove any external approval."
     ],
     "id": "nodekit-proof-campaign-2026-07-20",
-    "nextMilestone": "Deploy and production-prove the read-only synthetic Founder Quest Graph, then export and publish an evidence-bound deck, video, and campaign.",
+    "nextMilestone": "Regenerate the evidence-bound deck and walkthrough from the verified Founder Quest production receipt, then publish only the exact approved campaign and preserve the resulting public-URL receipts.",
     "presentationTier": 4,
     "previousState": [
       "Agent application scaffolding, runtime, domain evaluation, browser QA, and release evidence were rebuilt manually per project.",
@@ -5596,14 +5950,35 @@
         "text": "The preregistered Agentic RL live-model baseline failed closed when the Azure-only, zero-data-retention OpenRouter route returned HTTP 404; no retry, fallback, token usage, or cost was accepted."
       },
       {
-        "evidenceIds": [],
+        "evidenceIds": [
+          "E12_FOUNDER_QUEST_PRODUCTION",
+          "E13_FOUNDER_QUEST_RELEASE"
+        ],
         "id": "C5_FOUNDER_QUEST_PRODUCT",
         "limitations": [
-          "This claim must remain future tense until deployment and fresh-user browser proof pass."
-        ],
-        "scope": {},
-        "status": "planned",
-        "text": "Founder Quest Graph provides a read-only synthetic quest rail, bounded graph workspace, source-backed answer panel, and proof surface on an exact hosted revision."
+          "The journey is synthetic and read-only; no durable writes or remote Neo4j writes occur.",
+          "The 15 hosted checks and four isolated browser contexts prove this bounded production journey, not government, bank, legal, tax, regulatory, or other external approval."
+        ],
+        "scope": {
+          "appHash": "973ea7cbd8039e963bab1ff604bc0180bf0457f9a334b9b9dc0f77062f103e20",
+          "artifactManifestHashesVerified": 25,
+          "commit": "dc5fba2467576d5ded3d3ac6bf4d142316410c86",
+          "configHash": "973ea7cbd8039e963bab1ff604bc0180bf0457f9a334b9b9dc0f77062f103e20",
+          "evidenceCommit": "04579137a85f4ce18db61e6e7c0f25ff7b1d42b6",
+          "graphRevision": "ng1_c9334138",
+          "hostedChecksPassed": 15,
+          "hostedDeploymentCertified": true,
+          "isolatedBrowserContexts": 4,
+          "productionReceiptDigest": "023154fb77698b8704932ccaa9a0736a252a6de8b1ea46da3f76675ffac9f49c",
+          "productionUrl": "https://founder-quest-graph.vercel.app/",
+          "releaseAuditIssues": 0,
+          "releaseLevel": "production-certified",
+          "releaseReady": true,
+          "testsPassed": 18,
+          "unifiedReleaseReceiptDigest": "3366a2466bfed64e07c70324babbb9d2eb369965e7e1930c9f00909b199bb5a5"
+        },
+        "status": "verified",
+        "text": "Founder Quest Graph provides a read-only synthetic quest rail, bounded graph workspace, source-backed answer panel, and proof surface on an exact production revision that passed all 15 hosted checks."
       },
       {
         "evidenceIds": [
@@ -5671,7 +6046,7 @@
       {
         "id": "L5_FOUNDERQUEST_SYNTHETIC",
         "severity": "product-boundary",
-        "text": "Founder Quest Graph uses a fictional California LLC. Synthetic receipts may prove workflow readiness but never government, bank, insurance, payment-provider, legal, tax, or regulatory approval."
+        "text": "Founder Quest Graph uses a fictional California LLC in a read-only production journey. It performs no durable writes or remote Neo4j writes. Its receipts prove the bounded hosted workflow, never government, bank, insurance, payment-provider, legal, tax, regulatory, or other external approval."
       },
       {
         "id": "L6_NO_ANTHROPIC_AFFILIATION",
@@ -5688,7 +6063,7 @@
   }
 }
 Disclaimer: User supplied
-[source_eb5bb5f501f64e2f3fef3daf2cf79fa1] NodeKit evidence index
+[source_5511824e405b08e12b749fa04a98fd3f] NodeKit evidence index
 Citation: Uploaded file: NodeKit evidence index
 {
   "evidence": [
@@ -5767,15 +6142,29 @@
       "kind": "continuous-integration",
       "scope": "agentic-rl-research-lab@e1b114c486fbe26703688ab6481331659081b083; offline quality workflow passed",
       "url": "https://github.com/HomenShum/agentic-rl-research-lab/actions/runs/29799453044"
+    },
+    {
+      "id": "E12_FOUNDER_QUEST_PRODUCTION",
+      "kind": "production-browser-proof",
+      "receiptDigest": "023154fb77698b8704932ccaa9a0736a252a6de8b1ea46da3f76675ffac9f49c",
+      "scope": "founder-quest-graph@dc5fba2467576d5ded3d3ac6bf4d142316410c86; evidence 04579137a85f4ce18db61e6e7c0f25ff7b1d42b6; app/config 973ea7cbd8039e963bab1ff604bc0180bf0457f9a334b9b9dc0f77062f103e20; graph ng1_c9334138; 15/15 hosted checks; four isolated desktop/mobile light/dark contexts; zero browser, network, or cross-origin errors; synthetic read-only; no durable or remote Neo4j writes",
+      "url": "https://founder-quest-graph.vercel.app/"
+    },
+    {
+      "id": "E13_FOUNDER_QUEST_RELEASE",
+      "kind": "public-release",
+      "receiptDigest": "3366a2466bfed64e07c70324babbb9d2eb369965e7e1930c9f00909b199bb5a5",
+      "scope": "v0.1.1-production-certified; releaseReady=true; hostedDeploymentCertified=true; 18/18 tests; 25/25 artifact-manifest hashes verified byte-for-byte in a fresh Windows worktree; final independent release re-audit found zero remaining issues",
+      "url": "https://github.com/HomenShum/founder-quest-graph/releases/tag/v0.1.1-production-certified"
     }
   ],
   "schemaVersion": "nodekit.evidence-index/v1"
 }
 Disclaimer: User supplied
-[source_627f2cf2736066cd2c65dd72c5897641] NodeKit slide design plans
+[source_8c6f5fffd84efed8377f8fa8e8f5f68a] NodeKit slide design plans
 Citation: Uploaded file: NodeKit slide design plans
 {
-  "communicationJob": "By the end, a technical reviewer should understand what NodeKit now proves, which real product slices support the claim, and which release gates remain open.",
+  "communicationJob": "By the end, a technical reviewer should understand what NodeKit now proves, which real product slices support the claim, and which artifact and publication gates remain open.",
   "schemaVersion": "nodeslide.design-plan/v1",
   "slides": [
     {
@@ -5915,26 +6304,29 @@
     },
     {
       "audienceQuestion": "What does the graph make possible for a user?",
-      "body": "After an exact hosted revision and fresh-user journey pass, the planned read-only demo will connect quests, sources, and proof.",
+      "body": "Read-only Founder Quest connects quests, a bounded graph, sourced answers, authority boundaries, and proof in four isolated browser contexts.",
       "bullets": [
-        "Quest rail plus bounded graph",
-        "Source-backed answer plus authority class",
-        "No hosted-revision proof yet"
+        "Source dc5fba2 · evidence 0457913",
+        "App/config 973ea7cb · graph ng1_c9334138",
+        "18 / 18 tests · 25 / 25 artifact hashes"
       ],
       "claimIds": [
         "C5_FOUNDER_QUEST_PRODUCT"
       ],
       "density": "medium",
-      "dominantVisual": "Optional draft Founder Quest screenshot with quest rail, bounded graph, answer panel, and proof strip.",
-      "evidenceIds": [],
+      "dominantVisual": "Verified production Founder Quest view with quest rail, bounded graph, answer panel, and proof strip.",
+      "evidenceIds": [
+        "E12_FOUNDER_QUEST_PRODUCTION",
+        "E13_FOUNDER_QUEST_RELEASE"
+      ],
       "id": "S6",
       "job": "Introduce Founder Quest as the connected product surface.",
       "metric": {
-        "label": "hosted revision and fresh-user proof still required",
-        "value": "PLANNED"
+        "label": "hosted checks passed; synthetic and read-only",
+        "value": "15 / 15"
       },
       "narrativeRole": "product-reveal",
-      "takeaway": "Founder Quest remains planned until hosted and fresh-user proof pass."
+      "takeaway": "Founder Quest passed all 15 hosted checks on one exact production revision."
     },
     {
       "audienceQuestion": "How would a researcher use this today?",
@@ -5964,7 +6356,7 @@
     },
     {
       "audienceQuestion": "How do the pieces improve, and what should reviewers do next?",
-      "body": "Research, build, evaluation, proof, presentation, and feedback can watch one another; only external sources, commits, artifacts, and outcomes close the graph.",
+      "body": "Research, build, evaluation, proof, presentation, and feedback can watch one another. Only external anchors close the graph.",
       "bullets": [
         "Researcher, builder, or operator",
         "Sources, commits, exports, and outcomes",
@@ -8766,7 +9158,7 @@
                 <a:ea typeface="Arial" pitchFamily="34" charset="-122"/>
                 <a:cs typeface="Arial" pitchFamily="34" charset="-120"/>
               </a:rPr>
-              <a:t>Founder Quest remains planned until hosted and fresh-user proof pass.</a:t>
+              <a:t>Founder Quest passed all 15 hosted checks on one exact production revision.</a:t>
             </a:r>
             <a:endParaRPr lang="en-US" sz="3800" dirty="0"/>
           </a:p>
@@ -8810,7 +9202,7 @@
                 <a:ea typeface="Arial" pitchFamily="34" charset="-122"/>
                 <a:cs typeface="Arial" pitchFamily="34" charset="-120"/>
               </a:rPr>
-              <a:t>After an exact hosted revision and fresh-user journey pass, the planned read-only demo will connect quests, sources, and proof.</a:t>
+              <a:t>Read-only Founder Quest connects quests, a bounded graph, sourced answers, authority boundaries, and proof in four isolated browser contexts.</a:t>
             </a:r>
             <a:endParaRPr lang="en-US" sz="1900" dirty="0"/>
           </a:p>
@@ -8854,7 +9246,7 @@
                 <a:ea typeface="Arial" pitchFamily="34" charset="-122"/>
                 <a:cs typeface="Arial" pitchFamily="34" charset="-120"/>
               </a:rPr>
-              <a:t>01  Quest rail plus bounded graph</a:t>
+              <a:t>01  Source dc5fba2 · evidence 0457913</a:t>
             </a:r>
             <a:endParaRPr lang="en-US" sz="1700" dirty="0"/>
           </a:p>
@@ -8898,7 +9290,7 @@
                 <a:ea typeface="Arial" pitchFamily="34" charset="-122"/>
                 <a:cs typeface="Arial" pitchFamily="34" charset="-120"/>
               </a:rPr>
-              <a:t>02  Source-backed answer plus authority class</a:t>
+              <a:t>02  App/config 973ea7cb · graph ng1_c9334138</a:t>
             </a:r>
             <a:endParaRPr lang="en-US" sz="1700" dirty="0"/>
           </a:p>
@@ -8942,43 +9334,26 @@
                 <a:ea typeface="Arial" pitchFamily="34" charset="-122"/>
                 <a:cs typeface="Arial" pitchFamily="34" charset="-120"/>
               </a:rPr>
-              <a:t>03  No hosted-revision proof yet</a:t>
+              <a:t>03  18 / 18 tests · 25 / 25 artifact hashes</a:t>
             </a:r>
             <a:endParaRPr lang="en-US" sz="1700" dirty="0"/>
           </a:p>
         </p:txBody>
       </p:sp>
-      <p:sp>
-        <p:nvSpPr>
-          <p:cNvPr id="9" name="element_d298a0c97352e0958463d72cb8eff098:fallback-shape"/>
-          <p:cNvSpPr/>
+      <p:pic>
+        <p:nvPicPr>
+          <p:cNvPr id="9" name="element_d298a0c97352e0958463d72cb8eff098 [static image fallback]" descr="Founder Quest verified read-only production product view">    </p:cNvPr>
+          <p:cNvPicPr>
+            <a:picLocks noChangeAspect="1"/>
+          </p:cNvPicPr>
           <p:nvPr/>
-        </p:nvSpPr>
-        <p:spPr>
-          <a:xfrm>
-            <a:off x="731502" y="2674620"/>
-            <a:ext cx="4754761" cy="2606040"/>
-          </a:xfrm>
-          <a:prstGeom prst="roundRect">
-            <a:avLst/>
-          </a:prstGeom>
-          <a:solidFill>
-            <a:srgbClr val="DCECF0"/>
-          </a:solidFill>
-          <a:ln w="19050">
-            <a:solidFill>
-              <a:srgbClr val="CFDCE0"/>
-            </a:solidFill>
-            <a:prstDash val="dash"/>
-          </a:ln>
-        </p:spPr>
-      </p:sp>
-      <p:sp>
-        <p:nvSpPr>
-          <p:cNvPr id="10" name="element_d298a0c97352e0958463d72cb8eff098:fallback-label"/>
-          <p:cNvSpPr/>
-          <p:nvPr/>
-        </p:nvSpPr>
+        </p:nvPicPr>
+        <p:blipFill>
+          <a:blip r:embed="rId1"/>
+          <a:stretch>
+            <a:fillRect/>
+          </a:stretch>
+        </p:blipFill>
         <p:spPr>
           <a:xfrm>
             <a:off x="731502" y="2674620"/>
@@ -8987,70 +9362,11 @@
           <a:prstGeom prst="rect">
             <a:avLst/>
           </a:prstGeom>
-          <a:noFill/>
-          <a:ln/>
         </p:spPr>
-        <p:txBody>
-          <a:bodyPr wrap="square" lIns="101600" tIns="101600" rIns="101600" bIns="101600" rtlCol="0" anchor="ctr">
-            <a:normAutofit/>
-          </a:bodyPr>
-          <a:lstStyle/>
-          <a:p>
-            <a:pPr algn="ctr" indent="0" marL="0">
-              <a:buNone/>
-            </a:pPr>
-            <a:r>
-              <a:rPr lang="en-US" sz="1400" dirty="0">
-                <a:solidFill>
-                  <a:srgbClr val="60727B"/>
-                </a:solidFill>
-                <a:latin typeface="Geist Variable" pitchFamily="34" charset="0"/>
-                <a:ea typeface="Geist Variable" pitchFamily="34" charset="-122"/>
-                <a:cs typeface="Geist Variable" pitchFamily="34" charset="-120"/>
-              </a:rPr>
-              <a:t>Founder Quest product view, draft placeholder</a:t>
-            </a:r>
-            <a:endParaRPr lang="en-US" sz="1400" dirty="0"/>
-          </a:p>
-          <a:p>
-            <a:pPr algn="ctr" indent="0" marL="0">
-              <a:buNone/>
-            </a:pPr>
-            <a:r>
-              <a:rPr lang="en-US" sz="1400" dirty="0">
-                <a:solidFill>
-                  <a:srgbClr val="60727B"/>
-                </a:solidFill>
-                <a:latin typeface="Geist Variable" pitchFamily="34" charset="0"/>
-                <a:ea typeface="Geist Variable" pitchFamily="34" charset="-122"/>
-                <a:cs typeface="Geist Variable" pitchFamily="34" charset="-120"/>
-              </a:rPr>
-              <a:t>Replace image</a:t>
-            </a:r>
-            <a:endParaRPr lang="en-US" sz="1400" dirty="0"/>
-          </a:p>
-          <a:p>
-            <a:pPr algn="ctr" indent="0" marL="0">
-              <a:buNone/>
-            </a:pPr>
-            <a:r>
-              <a:rPr lang="en-US" sz="1400" dirty="0">
-                <a:solidFill>
-                  <a:srgbClr val="60727B"/>
-                </a:solidFill>
-                <a:latin typeface="Geist Variable" pitchFamily="34" charset="0"/>
-                <a:ea typeface="Geist Variable" pitchFamily="34" charset="-122"/>
-                <a:cs typeface="Geist Variable" pitchFamily="34" charset="-120"/>
-              </a:rPr>
-              <a:t>Synthetic draft</a:t>
-            </a:r>
-            <a:endParaRPr lang="en-US" sz="1400" dirty="0"/>
-          </a:p>
-        </p:txBody>
-      </p:sp>
-      <p:sp>
-        <p:nvSpPr>
-          <p:cNvPr id="11" name="element_fc25595fb847a8ef16d028139f458baf"/>
+      </p:pic>
+      <p:sp>
+        <p:nvSpPr>
+          <p:cNvPr id="10" name="element_fc25595fb847a8ef16d028139f458baf"/>
           <p:cNvSpPr txBox="1"/>
           <p:nvPr/>
         </p:nvSpPr>
@@ -9086,7 +9402,7 @@
                 <a:ea typeface="Arial" pitchFamily="34" charset="-122"/>
                 <a:cs typeface="Arial" pitchFamily="34" charset="-120"/>
               </a:rPr>
-              <a:t>Draft placeholder; hosted screenshot not supplied.</a:t>
+              <a:t>Production screenshot; verified scope remains synthetic and read-only.</a:t>
             </a:r>
             <a:endParaRPr lang="en-US" sz="1400" dirty="0"/>
           </a:p>
@@ -9094,7 +9410,7 @@
       </p:sp>
       <p:sp>
         <p:nvSpPr>
-          <p:cNvPr id="12" name="element_9378550d04361975d83d4ffe06c3637d"/>
+          <p:cNvPr id="11" name="element_9378550d04361975d83d4ffe06c3637d"/>
           <p:cNvSpPr txBox="1"/>
           <p:nvPr/>
         </p:nvSpPr>
@@ -9138,7 +9454,7 @@
       </p:sp>
       <p:sp>
         <p:nvSpPr>
-          <p:cNvPr id="13" name="element_f27c037df2bc5c8c15d1d9038bd76d40"/>
+          <p:cNvPr id="12" name="element_f27c037df2bc5c8c15d1d9038bd76d40"/>
           <p:cNvSpPr txBox="1"/>
           <p:nvPr/>
         </p:nvSpPr>
@@ -9820,7 +10136,7 @@
                 <a:ea typeface="Arial" pitchFamily="34" charset="-122"/>
                 <a:cs typeface="Arial" pitchFamily="34" charset="-120"/>
               </a:rPr>
-              <a:t>Research, build, evaluation, proof, presentation, and feedback can watch one another; only external sources, commits, artifacts, and outcomes close the graph.</a:t>
+              <a:t>Research, build, evaluation, proof, presentation, and feedback can watch one another. Only external anchors close the graph.</a:t>
             </a:r>
             <a:endParaRPr lang="en-US" sz="1900" dirty="0"/>
           </a:p>

</xml_diff>